<commit_message>
Add final 5-slide PowerPoint with embedded notes & live link, and separate Speaker Notes PDF guide
</commit_message>
<xml_diff>
--- a/CommentGuard_AI_Presentation.pptx
+++ b/CommentGuard_AI_Presentation.pptx
@@ -6,9 +6,10 @@
   </p:sldMasterIdLst>
   <p:sldIdLst>
     <p:sldId id="256" r:id="rId7"/>
-    <p:sldId id="257" r:id="rId8"/>
-    <p:sldId id="258" r:id="rId9"/>
-    <p:sldId id="259" r:id="rId10"/>
+    <p:sldId id="257" r:id="rId9"/>
+    <p:sldId id="258" r:id="rId10"/>
+    <p:sldId id="259" r:id="rId11"/>
+    <p:sldId id="260" r:id="rId12"/>
   </p:sldIdLst>
   <p:sldSz cx="12191695" cy="6858000" type="screen4x3"/>
   <p:notesSz cx="6858000" cy="9144000"/>
@@ -108,6 +109,823 @@
     </a:lvl9pPr>
   </p:defaultTextStyle>
 </p:presentation>
+</file>
+
+<file path=ppt/notesMasters/notesMaster1.xml><?xml version="1.0" encoding="utf-8"?>
+<p:notesMaster xmlns:a="http://schemas.openxmlformats.org/drawingml/2006/main" xmlns:p="http://schemas.openxmlformats.org/presentationml/2006/main" xmlns:r="http://schemas.openxmlformats.org/officeDocument/2006/relationships">
+  <p:cSld>
+    <p:bg>
+      <p:bgRef idx="1001">
+        <a:schemeClr val="bg1"/>
+      </p:bgRef>
+    </p:bg>
+    <p:spTree>
+      <p:nvGrpSpPr>
+        <p:cNvPr id="1" name=""/>
+        <p:cNvGrpSpPr/>
+        <p:nvPr/>
+      </p:nvGrpSpPr>
+      <p:grpSpPr>
+        <a:xfrm>
+          <a:off x="0" y="0"/>
+          <a:ext cx="0" cy="0"/>
+          <a:chOff x="0" y="0"/>
+          <a:chExt cx="0" cy="0"/>
+        </a:xfrm>
+      </p:grpSpPr>
+      <p:sp>
+        <p:nvSpPr>
+          <p:cNvPr id="2" name="Header Placeholder 1"/>
+          <p:cNvSpPr>
+            <a:spLocks noGrp="1"/>
+          </p:cNvSpPr>
+          <p:nvPr>
+            <p:ph type="hdr" sz="quarter"/>
+          </p:nvPr>
+        </p:nvSpPr>
+        <p:spPr>
+          <a:xfrm>
+            <a:off x="0" y="0"/>
+            <a:ext cx="2971800" cy="457200"/>
+          </a:xfrm>
+          <a:prstGeom prst="rect">
+            <a:avLst/>
+          </a:prstGeom>
+        </p:spPr>
+        <p:txBody>
+          <a:bodyPr vert="horz" lIns="91440" tIns="45720" rIns="91440" bIns="45720" rtlCol="0"/>
+          <a:lstStyle>
+            <a:lvl1pPr algn="l">
+              <a:defRPr sz="1200"/>
+            </a:lvl1pPr>
+          </a:lstStyle>
+          <a:p>
+            <a:endParaRPr lang="en-US"/>
+          </a:p>
+        </p:txBody>
+      </p:sp>
+      <p:sp>
+        <p:nvSpPr>
+          <p:cNvPr id="3" name="Date Placeholder 2"/>
+          <p:cNvSpPr>
+            <a:spLocks noGrp="1"/>
+          </p:cNvSpPr>
+          <p:nvPr>
+            <p:ph type="dt" idx="1"/>
+          </p:nvPr>
+        </p:nvSpPr>
+        <p:spPr>
+          <a:xfrm>
+            <a:off x="3884613" y="0"/>
+            <a:ext cx="2971800" cy="457200"/>
+          </a:xfrm>
+          <a:prstGeom prst="rect">
+            <a:avLst/>
+          </a:prstGeom>
+        </p:spPr>
+        <p:txBody>
+          <a:bodyPr vert="horz" lIns="91440" tIns="45720" rIns="91440" bIns="45720" rtlCol="0"/>
+          <a:lstStyle>
+            <a:lvl1pPr algn="r">
+              <a:defRPr sz="1200"/>
+            </a:lvl1pPr>
+          </a:lstStyle>
+          <a:p>
+            <a:fld id="{0F89C1C7-3DCD-1040-A9CF-14679D8B5DDD}" type="datetimeFigureOut">
+              <a:rPr lang="en-US" smtClean="0"/>
+              <a:t>10/17/16</a:t>
+            </a:fld>
+            <a:endParaRPr lang="en-US"/>
+          </a:p>
+        </p:txBody>
+      </p:sp>
+      <p:sp>
+        <p:nvSpPr>
+          <p:cNvPr id="4" name="Slide Image Placeholder 3"/>
+          <p:cNvSpPr>
+            <a:spLocks noGrp="1" noRot="1" noChangeAspect="1"/>
+          </p:cNvSpPr>
+          <p:nvPr>
+            <p:ph type="sldImg" idx="2"/>
+          </p:nvPr>
+        </p:nvSpPr>
+        <p:spPr>
+          <a:xfrm>
+            <a:off x="1143000" y="685800"/>
+            <a:ext cx="4572000" cy="3429000"/>
+          </a:xfrm>
+          <a:prstGeom prst="rect">
+            <a:avLst/>
+          </a:prstGeom>
+          <a:noFill/>
+          <a:ln w="12700">
+            <a:solidFill>
+              <a:prstClr val="black"/>
+            </a:solidFill>
+          </a:ln>
+        </p:spPr>
+        <p:txBody>
+          <a:bodyPr vert="horz" lIns="91440" tIns="45720" rIns="91440" bIns="45720" rtlCol="0" anchor="ctr"/>
+          <a:lstStyle/>
+          <a:p>
+            <a:endParaRPr lang="en-US"/>
+          </a:p>
+        </p:txBody>
+      </p:sp>
+      <p:sp>
+        <p:nvSpPr>
+          <p:cNvPr id="5" name="Notes Placeholder 4"/>
+          <p:cNvSpPr>
+            <a:spLocks noGrp="1"/>
+          </p:cNvSpPr>
+          <p:nvPr>
+            <p:ph type="body" sz="quarter" idx="3"/>
+          </p:nvPr>
+        </p:nvSpPr>
+        <p:spPr>
+          <a:xfrm>
+            <a:off x="685800" y="4343400"/>
+            <a:ext cx="5486400" cy="4114800"/>
+          </a:xfrm>
+          <a:prstGeom prst="rect">
+            <a:avLst/>
+          </a:prstGeom>
+        </p:spPr>
+        <p:txBody>
+          <a:bodyPr vert="horz" lIns="91440" tIns="45720" rIns="91440" bIns="45720" rtlCol="0"/>
+          <a:lstStyle/>
+          <a:p>
+            <a:pPr lvl="0"/>
+            <a:r>
+              <a:rPr lang="en-US" smtClean="0"/>
+              <a:t>Click to edit Master text styles</a:t>
+            </a:r>
+          </a:p>
+          <a:p>
+            <a:pPr lvl="1"/>
+            <a:r>
+              <a:rPr lang="en-US" smtClean="0"/>
+              <a:t>Second level</a:t>
+            </a:r>
+          </a:p>
+          <a:p>
+            <a:pPr lvl="2"/>
+            <a:r>
+              <a:rPr lang="en-US" smtClean="0"/>
+              <a:t>Third level</a:t>
+            </a:r>
+          </a:p>
+          <a:p>
+            <a:pPr lvl="3"/>
+            <a:r>
+              <a:rPr lang="en-US" smtClean="0"/>
+              <a:t>Fourth level</a:t>
+            </a:r>
+          </a:p>
+          <a:p>
+            <a:pPr lvl="4"/>
+            <a:r>
+              <a:rPr lang="en-US" smtClean="0"/>
+              <a:t>Fifth level</a:t>
+            </a:r>
+            <a:endParaRPr lang="en-US"/>
+          </a:p>
+        </p:txBody>
+      </p:sp>
+      <p:sp>
+        <p:nvSpPr>
+          <p:cNvPr id="6" name="Footer Placeholder 5"/>
+          <p:cNvSpPr>
+            <a:spLocks noGrp="1"/>
+          </p:cNvSpPr>
+          <p:nvPr>
+            <p:ph type="ftr" sz="quarter" idx="4"/>
+          </p:nvPr>
+        </p:nvSpPr>
+        <p:spPr>
+          <a:xfrm>
+            <a:off x="0" y="8685213"/>
+            <a:ext cx="2971800" cy="457200"/>
+          </a:xfrm>
+          <a:prstGeom prst="rect">
+            <a:avLst/>
+          </a:prstGeom>
+        </p:spPr>
+        <p:txBody>
+          <a:bodyPr vert="horz" lIns="91440" tIns="45720" rIns="91440" bIns="45720" rtlCol="0" anchor="b"/>
+          <a:lstStyle>
+            <a:lvl1pPr algn="l">
+              <a:defRPr sz="1200"/>
+            </a:lvl1pPr>
+          </a:lstStyle>
+          <a:p>
+            <a:endParaRPr lang="en-US"/>
+          </a:p>
+        </p:txBody>
+      </p:sp>
+      <p:sp>
+        <p:nvSpPr>
+          <p:cNvPr id="7" name="Slide Number Placeholder 6"/>
+          <p:cNvSpPr>
+            <a:spLocks noGrp="1"/>
+          </p:cNvSpPr>
+          <p:nvPr>
+            <p:ph type="sldNum" sz="quarter" idx="5"/>
+          </p:nvPr>
+        </p:nvSpPr>
+        <p:spPr>
+          <a:xfrm>
+            <a:off x="3884613" y="8685213"/>
+            <a:ext cx="2971800" cy="457200"/>
+          </a:xfrm>
+          <a:prstGeom prst="rect">
+            <a:avLst/>
+          </a:prstGeom>
+        </p:spPr>
+        <p:txBody>
+          <a:bodyPr vert="horz" lIns="91440" tIns="45720" rIns="91440" bIns="45720" rtlCol="0" anchor="b"/>
+          <a:lstStyle>
+            <a:lvl1pPr algn="r">
+              <a:defRPr sz="1200"/>
+            </a:lvl1pPr>
+          </a:lstStyle>
+          <a:p>
+            <a:fld id="{BB5E49A5-4136-284D-997B-48E1D791AD67}" type="slidenum">
+              <a:rPr lang="en-US" smtClean="0"/>
+              <a:t>‹#›</a:t>
+            </a:fld>
+            <a:endParaRPr lang="en-US"/>
+          </a:p>
+        </p:txBody>
+      </p:sp>
+    </p:spTree>
+    <p:extLst>
+      <p:ext uri="{BB962C8B-B14F-4D97-AF65-F5344CB8AC3E}">
+        <p14:creationId xmlns:p14="http://schemas.microsoft.com/office/powerpoint/2010/main" val="2623252185"/>
+      </p:ext>
+    </p:extLst>
+  </p:cSld>
+  <p:clrMap bg1="lt1" tx1="dk1" bg2="lt2" tx2="dk2" accent1="accent1" accent2="accent2" accent3="accent3" accent4="accent4" accent5="accent5" accent6="accent6" hlink="hlink" folHlink="folHlink"/>
+  <p:notesStyle>
+    <a:lvl1pPr marL="0" algn="l" defTabSz="457200" rtl="0" eaLnBrk="1" latinLnBrk="0" hangingPunct="1">
+      <a:defRPr sz="1200" kern="1200">
+        <a:solidFill>
+          <a:schemeClr val="tx1"/>
+        </a:solidFill>
+        <a:latin typeface="+mn-lt"/>
+        <a:ea typeface="+mn-ea"/>
+        <a:cs typeface="+mn-cs"/>
+      </a:defRPr>
+    </a:lvl1pPr>
+    <a:lvl2pPr marL="457200" algn="l" defTabSz="457200" rtl="0" eaLnBrk="1" latinLnBrk="0" hangingPunct="1">
+      <a:defRPr sz="1200" kern="1200">
+        <a:solidFill>
+          <a:schemeClr val="tx1"/>
+        </a:solidFill>
+        <a:latin typeface="+mn-lt"/>
+        <a:ea typeface="+mn-ea"/>
+        <a:cs typeface="+mn-cs"/>
+      </a:defRPr>
+    </a:lvl2pPr>
+    <a:lvl3pPr marL="914400" algn="l" defTabSz="457200" rtl="0" eaLnBrk="1" latinLnBrk="0" hangingPunct="1">
+      <a:defRPr sz="1200" kern="1200">
+        <a:solidFill>
+          <a:schemeClr val="tx1"/>
+        </a:solidFill>
+        <a:latin typeface="+mn-lt"/>
+        <a:ea typeface="+mn-ea"/>
+        <a:cs typeface="+mn-cs"/>
+      </a:defRPr>
+    </a:lvl3pPr>
+    <a:lvl4pPr marL="1371600" algn="l" defTabSz="457200" rtl="0" eaLnBrk="1" latinLnBrk="0" hangingPunct="1">
+      <a:defRPr sz="1200" kern="1200">
+        <a:solidFill>
+          <a:schemeClr val="tx1"/>
+        </a:solidFill>
+        <a:latin typeface="+mn-lt"/>
+        <a:ea typeface="+mn-ea"/>
+        <a:cs typeface="+mn-cs"/>
+      </a:defRPr>
+    </a:lvl4pPr>
+    <a:lvl5pPr marL="1828800" algn="l" defTabSz="457200" rtl="0" eaLnBrk="1" latinLnBrk="0" hangingPunct="1">
+      <a:defRPr sz="1200" kern="1200">
+        <a:solidFill>
+          <a:schemeClr val="tx1"/>
+        </a:solidFill>
+        <a:latin typeface="+mn-lt"/>
+        <a:ea typeface="+mn-ea"/>
+        <a:cs typeface="+mn-cs"/>
+      </a:defRPr>
+    </a:lvl5pPr>
+    <a:lvl6pPr marL="2286000" algn="l" defTabSz="457200" rtl="0" eaLnBrk="1" latinLnBrk="0" hangingPunct="1">
+      <a:defRPr sz="1200" kern="1200">
+        <a:solidFill>
+          <a:schemeClr val="tx1"/>
+        </a:solidFill>
+        <a:latin typeface="+mn-lt"/>
+        <a:ea typeface="+mn-ea"/>
+        <a:cs typeface="+mn-cs"/>
+      </a:defRPr>
+    </a:lvl6pPr>
+    <a:lvl7pPr marL="2743200" algn="l" defTabSz="457200" rtl="0" eaLnBrk="1" latinLnBrk="0" hangingPunct="1">
+      <a:defRPr sz="1200" kern="1200">
+        <a:solidFill>
+          <a:schemeClr val="tx1"/>
+        </a:solidFill>
+        <a:latin typeface="+mn-lt"/>
+        <a:ea typeface="+mn-ea"/>
+        <a:cs typeface="+mn-cs"/>
+      </a:defRPr>
+    </a:lvl7pPr>
+    <a:lvl8pPr marL="3200400" algn="l" defTabSz="457200" rtl="0" eaLnBrk="1" latinLnBrk="0" hangingPunct="1">
+      <a:defRPr sz="1200" kern="1200">
+        <a:solidFill>
+          <a:schemeClr val="tx1"/>
+        </a:solidFill>
+        <a:latin typeface="+mn-lt"/>
+        <a:ea typeface="+mn-ea"/>
+        <a:cs typeface="+mn-cs"/>
+      </a:defRPr>
+    </a:lvl8pPr>
+    <a:lvl9pPr marL="3657600" algn="l" defTabSz="457200" rtl="0" eaLnBrk="1" latinLnBrk="0" hangingPunct="1">
+      <a:defRPr sz="1200" kern="1200">
+        <a:solidFill>
+          <a:schemeClr val="tx1"/>
+        </a:solidFill>
+        <a:latin typeface="+mn-lt"/>
+        <a:ea typeface="+mn-ea"/>
+        <a:cs typeface="+mn-cs"/>
+      </a:defRPr>
+    </a:lvl9pPr>
+  </p:notesStyle>
+</p:notesMaster>
+</file>
+
+<file path=ppt/notesSlides/notesSlide1.xml><?xml version="1.0" encoding="utf-8"?>
+<p:notes xmlns:a="http://schemas.openxmlformats.org/drawingml/2006/main" xmlns:p="http://schemas.openxmlformats.org/presentationml/2006/main" xmlns:r="http://schemas.openxmlformats.org/officeDocument/2006/relationships">
+  <p:cSld>
+    <p:spTree>
+      <p:nvGrpSpPr>
+        <p:cNvPr id="1" name=""/>
+        <p:cNvGrpSpPr/>
+        <p:nvPr/>
+      </p:nvGrpSpPr>
+      <p:grpSpPr>
+        <a:xfrm>
+          <a:off x="0" y="0"/>
+          <a:ext cx="0" cy="0"/>
+          <a:chOff x="0" y="0"/>
+          <a:chExt cx="0" cy="0"/>
+        </a:xfrm>
+      </p:grpSpPr>
+      <p:sp>
+        <p:nvSpPr>
+          <p:cNvPr id="2" name="Slide Image Placeholder 1"/>
+          <p:cNvSpPr>
+            <a:spLocks noGrp="1"/>
+          </p:cNvSpPr>
+          <p:nvPr>
+            <p:ph type="sldImg" idx="2"/>
+          </p:nvPr>
+        </p:nvSpPr>
+        <p:spPr/>
+      </p:sp>
+      <p:sp>
+        <p:nvSpPr>
+          <p:cNvPr id="3" name="Notes Placeholder 2"/>
+          <p:cNvSpPr>
+            <a:spLocks noGrp="1"/>
+          </p:cNvSpPr>
+          <p:nvPr>
+            <p:ph type="body" idx="3" sz="quarter"/>
+          </p:nvPr>
+        </p:nvSpPr>
+        <p:spPr/>
+        <p:txBody>
+          <a:bodyPr/>
+          <a:lstStyle/>
+          <a:p>
+            <a:r>
+              <a:t>SLIDE 1 SPEAKER SCRIPT:</a:t>
+            </a:r>
+          </a:p>
+          <a:p>
+            <a:r>
+              <a:t>Good morning/afternoon, evaluators. My name is Dhanush Bheemsetty. Today I am presenting my solution for the Spam and Abuse Filter for Comments, designed for ITC Infotech's Eminence Drive.</a:t>
+            </a:r>
+          </a:p>
+          <a:p/>
+          <a:p>
+            <a:r>
+              <a:t>Let us look at the core challenge: A cooking video platform receives 20,000 user comments per day. However, the platform has only 2 human moderators. In an 8-hour workday, two moderators can realistically review around 1,000 to 1,200 comments. Manually checking 20,000 comments is physically impossible.</a:t>
+            </a:r>
+          </a:p>
+          <a:p/>
+          <a:p>
+            <a:r>
+              <a:t>My solution is CommentGuard AI: a 3-tier cascade combining deterministic AI rules, classical machine learning, and a small transformer (DistilBERT). It automatically processes 94% of traffic with high precision, leaving only around 320 truly ambiguous comments for the two moderators to review. Let me walk you through the architecture.</a:t>
+            </a:r>
+          </a:p>
+        </p:txBody>
+      </p:sp>
+      <p:sp>
+        <p:nvSpPr>
+          <p:cNvPr id="4" name="Slide Number Placeholder 3"/>
+          <p:cNvSpPr>
+            <a:spLocks noGrp="1"/>
+          </p:cNvSpPr>
+          <p:nvPr>
+            <p:ph type="sldNum" idx="5" sz="quarter"/>
+          </p:nvPr>
+        </p:nvSpPr>
+        <p:spPr/>
+      </p:sp>
+    </p:spTree>
+  </p:cSld>
+  <p:clrMapOvr>
+    <a:masterClrMapping/>
+  </p:clrMapOvr>
+</p:notes>
+</file>
+
+<file path=ppt/notesSlides/notesSlide2.xml><?xml version="1.0" encoding="utf-8"?>
+<p:notes xmlns:a="http://schemas.openxmlformats.org/drawingml/2006/main" xmlns:p="http://schemas.openxmlformats.org/presentationml/2006/main" xmlns:r="http://schemas.openxmlformats.org/officeDocument/2006/relationships">
+  <p:cSld>
+    <p:spTree>
+      <p:nvGrpSpPr>
+        <p:cNvPr id="1" name=""/>
+        <p:cNvGrpSpPr/>
+        <p:nvPr/>
+      </p:nvGrpSpPr>
+      <p:grpSpPr>
+        <a:xfrm>
+          <a:off x="0" y="0"/>
+          <a:ext cx="0" cy="0"/>
+          <a:chOff x="0" y="0"/>
+          <a:chExt cx="0" cy="0"/>
+        </a:xfrm>
+      </p:grpSpPr>
+      <p:sp>
+        <p:nvSpPr>
+          <p:cNvPr id="2" name="Slide Image Placeholder 1"/>
+          <p:cNvSpPr>
+            <a:spLocks noGrp="1"/>
+          </p:cNvSpPr>
+          <p:nvPr>
+            <p:ph type="sldImg" idx="2"/>
+          </p:nvPr>
+        </p:nvSpPr>
+        <p:spPr/>
+      </p:sp>
+      <p:sp>
+        <p:nvSpPr>
+          <p:cNvPr id="3" name="Notes Placeholder 2"/>
+          <p:cNvSpPr>
+            <a:spLocks noGrp="1"/>
+          </p:cNvSpPr>
+          <p:nvPr>
+            <p:ph type="body" idx="3" sz="quarter"/>
+          </p:nvPr>
+        </p:nvSpPr>
+        <p:spPr/>
+        <p:txBody>
+          <a:bodyPr/>
+          <a:lstStyle/>
+          <a:p>
+            <a:r>
+              <a:t>SLIDE 2 SPEAKER SCRIPT:</a:t>
+            </a:r>
+          </a:p>
+          <a:p>
+            <a:r>
+              <a:t>Now let's examine the 3-Tier Architecture. In machine learning, AI is the broad concept, ML is pattern learning, and Deep Learning uses multi-layer neural networks. Our design cascades all three.</a:t>
+            </a:r>
+          </a:p>
+          <a:p/>
+          <a:p>
+            <a:r>
+              <a:t>Tier 1 is Deterministic AI Rules. It runs in 1.2 milliseconds. It catches obvious bit.ly links, telegram handles, and explicit profanity at zero cost. It also contains our cooking allowlist to protect phrases like 'kill the heat'.</a:t>
+            </a:r>
+          </a:p>
+          <a:p/>
+          <a:p>
+            <a:r>
+              <a:t>Tier 2 is Classical ML. Using TF-IDF, caps ratio, and Logistic Regression, it scores bulk traffic in 4.8 milliseconds. For example, 'DM ME FOR CHEAP FOLLOWERS' has high caps and promo keywords, scoring 94% spam.</a:t>
+            </a:r>
+          </a:p>
+          <a:p/>
+          <a:p>
+            <a:r>
+              <a:t>Tier 3 is our Small Transformer—specifically DistilBERT with 66 million parameters. Why a small transformer instead of a huge LLM? Because DistilBERT runs in just 14 milliseconds on a normal CPU and costs less than $2 a month! Most importantly, it solves context: when someone says 'This recipe is killer, I would die for this!', DistilBERT understands this is enthusiastic praise, NOT violence, preventing false flags.</a:t>
+            </a:r>
+          </a:p>
+          <a:p/>
+          <a:p>
+            <a:r>
+              <a:t>Finally, Tier 4 is the two human moderators. They only receive the ~320 borderline cases where confidence is between 40% and 89%.</a:t>
+            </a:r>
+          </a:p>
+        </p:txBody>
+      </p:sp>
+      <p:sp>
+        <p:nvSpPr>
+          <p:cNvPr id="4" name="Slide Number Placeholder 3"/>
+          <p:cNvSpPr>
+            <a:spLocks noGrp="1"/>
+          </p:cNvSpPr>
+          <p:nvPr>
+            <p:ph type="sldNum" idx="5" sz="quarter"/>
+          </p:nvPr>
+        </p:nvSpPr>
+        <p:spPr/>
+      </p:sp>
+    </p:spTree>
+  </p:cSld>
+  <p:clrMapOvr>
+    <a:masterClrMapping/>
+  </p:clrMapOvr>
+</p:notes>
+</file>
+
+<file path=ppt/notesSlides/notesSlide3.xml><?xml version="1.0" encoding="utf-8"?>
+<p:notes xmlns:a="http://schemas.openxmlformats.org/drawingml/2006/main" xmlns:p="http://schemas.openxmlformats.org/presentationml/2006/main" xmlns:r="http://schemas.openxmlformats.org/officeDocument/2006/relationships">
+  <p:cSld>
+    <p:spTree>
+      <p:nvGrpSpPr>
+        <p:cNvPr id="1" name=""/>
+        <p:cNvGrpSpPr/>
+        <p:nvPr/>
+      </p:nvGrpSpPr>
+      <p:grpSpPr>
+        <a:xfrm>
+          <a:off x="0" y="0"/>
+          <a:ext cx="0" cy="0"/>
+          <a:chOff x="0" y="0"/>
+          <a:chExt cx="0" cy="0"/>
+        </a:xfrm>
+      </p:grpSpPr>
+      <p:sp>
+        <p:nvSpPr>
+          <p:cNvPr id="2" name="Slide Image Placeholder 1"/>
+          <p:cNvSpPr>
+            <a:spLocks noGrp="1"/>
+          </p:cNvSpPr>
+          <p:nvPr>
+            <p:ph type="sldImg" idx="2"/>
+          </p:nvPr>
+        </p:nvSpPr>
+        <p:spPr/>
+      </p:sp>
+      <p:sp>
+        <p:nvSpPr>
+          <p:cNvPr id="3" name="Notes Placeholder 2"/>
+          <p:cNvSpPr>
+            <a:spLocks noGrp="1"/>
+          </p:cNvSpPr>
+          <p:nvPr>
+            <p:ph type="body" idx="3" sz="quarter"/>
+          </p:nvPr>
+        </p:nvSpPr>
+        <p:spPr/>
+        <p:txBody>
+          <a:bodyPr/>
+          <a:lstStyle/>
+          <a:p>
+            <a:r>
+              <a:t>SLIDE 3 SPEAKER SCRIPT:</a:t>
+            </a:r>
+          </a:p>
+          <a:p>
+            <a:r>
+              <a:t>Slide 3 directly answers the first two questions from your problem statement.</a:t>
+            </a:r>
+          </a:p>
+          <a:p/>
+          <a:p>
+            <a:r>
+              <a:t>Question 1: How do we classify comments? We don't guess. We compute probability distributions P(fine), P(spam), and P(abusive). If confidence is 90% or higher, the AI takes automated action. If confidence is in the uncertain zone between 40% and 89%, it is classified as 'Unclear'.</a:t>
+            </a:r>
+          </a:p>
+          <a:p/>
+          <a:p>
+            <a:r>
+              <a:t>Question 2: What should happen to each category?</a:t>
+            </a:r>
+          </a:p>
+          <a:p>
+            <a:r>
+              <a:t>1. Fine comments—which make up about 57% or 11,400 comments—are auto-published immediately so genuine viewers aren't delayed.</a:t>
+            </a:r>
+          </a:p>
+          <a:p>
+            <a:r>
+              <a:t>2. Spam comments—about 21%—are auto-hidden and logged, triggering shadowbans if repeated.</a:t>
+            </a:r>
+          </a:p>
+          <a:p>
+            <a:r>
+              <a:t>3. Abusive comments—about 5%—are auto-hidden and flagged for policy review, issuing account strikes.</a:t>
+            </a:r>
+          </a:p>
+          <a:p>
+            <a:r>
+              <a:t>4. Unclear comments—the top 320 borderline cases—are routed to our 2 moderators. 160 comments each is very achievable in less than an hour, completely solving the human bottleneck.</a:t>
+            </a:r>
+          </a:p>
+        </p:txBody>
+      </p:sp>
+      <p:sp>
+        <p:nvSpPr>
+          <p:cNvPr id="4" name="Slide Number Placeholder 3"/>
+          <p:cNvSpPr>
+            <a:spLocks noGrp="1"/>
+          </p:cNvSpPr>
+          <p:nvPr>
+            <p:ph type="sldNum" idx="5" sz="quarter"/>
+          </p:nvPr>
+        </p:nvSpPr>
+        <p:spPr/>
+      </p:sp>
+    </p:spTree>
+  </p:cSld>
+  <p:clrMapOvr>
+    <a:masterClrMapping/>
+  </p:clrMapOvr>
+</p:notes>
+</file>
+
+<file path=ppt/notesSlides/notesSlide4.xml><?xml version="1.0" encoding="utf-8"?>
+<p:notes xmlns:a="http://schemas.openxmlformats.org/drawingml/2006/main" xmlns:p="http://schemas.openxmlformats.org/presentationml/2006/main" xmlns:r="http://schemas.openxmlformats.org/officeDocument/2006/relationships">
+  <p:cSld>
+    <p:spTree>
+      <p:nvGrpSpPr>
+        <p:cNvPr id="1" name=""/>
+        <p:cNvGrpSpPr/>
+        <p:nvPr/>
+      </p:nvGrpSpPr>
+      <p:grpSpPr>
+        <a:xfrm>
+          <a:off x="0" y="0"/>
+          <a:ext cx="0" cy="0"/>
+          <a:chOff x="0" y="0"/>
+          <a:chExt cx="0" cy="0"/>
+        </a:xfrm>
+      </p:grpSpPr>
+      <p:sp>
+        <p:nvSpPr>
+          <p:cNvPr id="2" name="Slide Image Placeholder 1"/>
+          <p:cNvSpPr>
+            <a:spLocks noGrp="1"/>
+          </p:cNvSpPr>
+          <p:nvPr>
+            <p:ph type="sldImg" idx="2"/>
+          </p:nvPr>
+        </p:nvSpPr>
+        <p:spPr/>
+      </p:sp>
+      <p:sp>
+        <p:nvSpPr>
+          <p:cNvPr id="3" name="Notes Placeholder 2"/>
+          <p:cNvSpPr>
+            <a:spLocks noGrp="1"/>
+          </p:cNvSpPr>
+          <p:nvPr>
+            <p:ph type="body" idx="3" sz="quarter"/>
+          </p:nvPr>
+        </p:nvSpPr>
+        <p:spPr/>
+        <p:txBody>
+          <a:bodyPr/>
+          <a:lstStyle/>
+          <a:p>
+            <a:r>
+              <a:t>SLIDE 4 SPEAKER SCRIPT:</a:t>
+            </a:r>
+          </a:p>
+          <a:p>
+            <a:r>
+              <a:t>Slide 4 addresses the remaining two questions: avoiding false positives and staying ahead of evolving spam.</a:t>
+            </a:r>
+          </a:p>
+          <a:p/>
+          <a:p>
+            <a:r>
+              <a:t>Question 3: How do we avoid hiding genuine comments? On cooking channels, words like 'kill the heat' or 'beat the eggs' look aggressive to dumb keyword filters. DistilBERT solves this with context awareness. Furthermore, we require 90% confidence to auto-hide. If there is doubt, we default to sending it to the human queue rather than hiding a fan's comment.</a:t>
+            </a:r>
+          </a:p>
+          <a:p/>
+          <a:p>
+            <a:r>
+              <a:t>Question 4: How do we keep up with new spam tricks? Spammers constantly mutate patterns using spaces like c-h-e-a-p or redirect links. We handle this through adversarial text normalization and an active learning loop. The 2 moderators generate ~300 verified labels daily. Every week, DistilBERT is fine-tuned on these labels in under 5 minutes, ensuring the model adapts continuously to new spam trends.</a:t>
+            </a:r>
+          </a:p>
+        </p:txBody>
+      </p:sp>
+      <p:sp>
+        <p:nvSpPr>
+          <p:cNvPr id="4" name="Slide Number Placeholder 3"/>
+          <p:cNvSpPr>
+            <a:spLocks noGrp="1"/>
+          </p:cNvSpPr>
+          <p:nvPr>
+            <p:ph type="sldNum" idx="5" sz="quarter"/>
+          </p:nvPr>
+        </p:nvSpPr>
+        <p:spPr/>
+      </p:sp>
+    </p:spTree>
+  </p:cSld>
+  <p:clrMapOvr>
+    <a:masterClrMapping/>
+  </p:clrMapOvr>
+</p:notes>
+</file>
+
+<file path=ppt/notesSlides/notesSlide5.xml><?xml version="1.0" encoding="utf-8"?>
+<p:notes xmlns:a="http://schemas.openxmlformats.org/drawingml/2006/main" xmlns:p="http://schemas.openxmlformats.org/presentationml/2006/main" xmlns:r="http://schemas.openxmlformats.org/officeDocument/2006/relationships">
+  <p:cSld>
+    <p:spTree>
+      <p:nvGrpSpPr>
+        <p:cNvPr id="1" name=""/>
+        <p:cNvGrpSpPr/>
+        <p:nvPr/>
+      </p:nvGrpSpPr>
+      <p:grpSpPr>
+        <a:xfrm>
+          <a:off x="0" y="0"/>
+          <a:ext cx="0" cy="0"/>
+          <a:chOff x="0" y="0"/>
+          <a:chExt cx="0" cy="0"/>
+        </a:xfrm>
+      </p:grpSpPr>
+      <p:sp>
+        <p:nvSpPr>
+          <p:cNvPr id="2" name="Slide Image Placeholder 1"/>
+          <p:cNvSpPr>
+            <a:spLocks noGrp="1"/>
+          </p:cNvSpPr>
+          <p:nvPr>
+            <p:ph type="sldImg" idx="2"/>
+          </p:nvPr>
+        </p:nvSpPr>
+        <p:spPr/>
+      </p:sp>
+      <p:sp>
+        <p:nvSpPr>
+          <p:cNvPr id="3" name="Notes Placeholder 2"/>
+          <p:cNvSpPr>
+            <a:spLocks noGrp="1"/>
+          </p:cNvSpPr>
+          <p:nvPr>
+            <p:ph type="body" idx="3" sz="quarter"/>
+          </p:nvPr>
+        </p:nvSpPr>
+        <p:spPr/>
+        <p:txBody>
+          <a:bodyPr/>
+          <a:lstStyle/>
+          <a:p>
+            <a:r>
+              <a:t>SLIDE 5 SPEAKER SCRIPT:</a:t>
+            </a:r>
+          </a:p>
+          <a:p>
+            <a:r>
+              <a:t>To conclude, I didn't just design the theory—I built and deployed the full working system. The live prototype is accessible right now at https://commentguard-ai.onrender.com/.</a:t>
+            </a:r>
+          </a:p>
+          <a:p/>
+          <a:p>
+            <a:r>
+              <a:t>In this prototype, you can fetch comments from real cooking videos, test any raw input sentence live to see the millisecond layer breakdown, review borderline comments in the moderator queue, and run a simulated weekly retraining loop.</a:t>
+            </a:r>
+          </a:p>
+          <a:p/>
+          <a:p>
+            <a:r>
+              <a:t>Thank you so much for your time and consideration. I would be thrilled to demonstrate the live system now or answer any technical questions.</a:t>
+            </a:r>
+          </a:p>
+        </p:txBody>
+      </p:sp>
+      <p:sp>
+        <p:nvSpPr>
+          <p:cNvPr id="4" name="Slide Number Placeholder 3"/>
+          <p:cNvSpPr>
+            <a:spLocks noGrp="1"/>
+          </p:cNvSpPr>
+          <p:nvPr>
+            <p:ph type="sldNum" idx="5" sz="quarter"/>
+          </p:nvPr>
+        </p:nvSpPr>
+        <p:spPr/>
+      </p:sp>
+    </p:spTree>
+  </p:cSld>
+  <p:clrMapOvr>
+    <a:masterClrMapping/>
+  </p:clrMapOvr>
+</p:notes>
 </file>
 
 <file path=ppt/slideLayouts/slideLayout1.xml><?xml version="1.0" encoding="utf-8"?>
@@ -3142,7 +3960,7 @@
         </p:nvSpPr>
         <p:spPr>
           <a:xfrm>
-            <a:off x="731520" y="731520"/>
+            <a:off x="731520" y="548640"/>
             <a:ext cx="10728655" cy="2011680"/>
           </a:xfrm>
           <a:prstGeom prst="rect">
@@ -3157,38 +3975,41 @@
           <a:lstStyle/>
           <a:p>
             <a:pPr>
-              <a:defRPr sz="3600" b="1">
+              <a:defRPr sz="1100" b="1">
+                <a:solidFill>
+                  <a:srgbClr val="D97706"/>
+                </a:solidFill>
+              </a:defRPr>
+            </a:pPr>
+            <a:r>
+              <a:t>ITC INFOTECH · EMINENCE CAMPUS DRIVE 2026 | INTERVIEW PRESENTATION</a:t>
+            </a:r>
+          </a:p>
+          <a:p>
+            <a:pPr>
+              <a:defRPr sz="3200" b="1">
                 <a:solidFill>
                   <a:srgbClr val="0F172A"/>
                 </a:solidFill>
               </a:defRPr>
             </a:pPr>
             <a:r>
-              <a:t>CommentGuard AI</a:t>
+              <a:t>CommentGuard AI: Spam &amp; Abuse Filter</a:t>
             </a:r>
           </a:p>
           <a:p>
             <a:pPr>
-              <a:defRPr sz="2000" b="1">
+              <a:spcBef>
+                <a:spcPts val="400"/>
+              </a:spcBef>
+              <a:defRPr sz="1300" b="1">
                 <a:solidFill>
                   <a:srgbClr val="059669"/>
                 </a:solidFill>
               </a:defRPr>
             </a:pPr>
             <a:r>
-              <a:t>Cascaded AI Moderation Architecture for Cooking Video Platforms</a:t>
-            </a:r>
-          </a:p>
-          <a:p>
-            <a:pPr>
-              <a:defRPr sz="1300">
-                <a:solidFill>
-                  <a:srgbClr val="64748B"/>
-                </a:solidFill>
-              </a:defRPr>
-            </a:pPr>
-            <a:r>
-              <a:t>Candidate: Bheemsetty Dhanush | Position: Eminence Campus Drive 2026</a:t>
+              <a:t>Candidate: Dhanush Bheemsetty  |  Email: dhanushbheemisetty0@gmail.com  |  Reg. No: 2200030834</a:t>
             </a:r>
           </a:p>
         </p:txBody>
@@ -3201,8 +4022,8 @@
         </p:nvSpPr>
         <p:spPr>
           <a:xfrm>
-            <a:off x="731520" y="2926080"/>
-            <a:ext cx="3429000" cy="3200400"/>
+            <a:off x="731520" y="2651760"/>
+            <a:ext cx="5212080" cy="3566160"/>
           </a:xfrm>
           <a:prstGeom prst="roundRect">
             <a:avLst/>
@@ -3246,8 +4067,8 @@
         </p:nvSpPr>
         <p:spPr>
           <a:xfrm>
-            <a:off x="1005840" y="3200400"/>
-            <a:ext cx="2880360" cy="2651760"/>
+            <a:off x="960120" y="2834640"/>
+            <a:ext cx="4754880" cy="3200400"/>
           </a:xfrm>
           <a:prstGeom prst="rect">
             <a:avLst/>
@@ -3263,31 +4084,120 @@
             <a:pPr>
               <a:defRPr sz="1600" b="1">
                 <a:solidFill>
-                  <a:srgbClr val="0F172A"/>
-                </a:solidFill>
-              </a:defRPr>
-            </a:pPr>
-            <a:r>
-              <a:t>The Challenge</a:t>
+                  <a:srgbClr val="E11D48"/>
+                </a:solidFill>
+              </a:defRPr>
+            </a:pPr>
+            <a:r>
+              <a:t>The Problem Statement (In Simple Words)</a:t>
             </a:r>
           </a:p>
           <a:p>
             <a:pPr>
               <a:spcBef>
-                <a:spcPts val="1000"/>
+                <a:spcPts val="600"/>
               </a:spcBef>
-              <a:defRPr sz="1200">
+              <a:defRPr b="1" sz="1100">
+                <a:solidFill>
+                  <a:srgbClr val="0F172A"/>
+                </a:solidFill>
+              </a:defRPr>
+            </a:pPr>
+            <a:r>
+              <a:t>• High Daily Traffic: </a:t>
+            </a:r>
+          </a:p>
+          <a:p>
+            <a:pPr>
+              <a:defRPr sz="1050">
                 <a:solidFill>
                   <a:srgbClr val="64748B"/>
                 </a:solidFill>
               </a:defRPr>
             </a:pPr>
             <a:r>
-              <a:t>20,000 comments/day across cooking videos.</a:t>
-            </a:r>
-            <a:br/>
-            <a:r>
-              <a:t>Spam links, abusive comments, and unauthorized promotions degrade creator engagement.</a:t>
+              <a:t>A popular cooking video platform receives 20,000 user comments every single day.</a:t>
+            </a:r>
+          </a:p>
+          <a:p>
+            <a:pPr>
+              <a:spcBef>
+                <a:spcPts val="600"/>
+              </a:spcBef>
+              <a:defRPr b="1" sz="1100">
+                <a:solidFill>
+                  <a:srgbClr val="0F172A"/>
+                </a:solidFill>
+              </a:defRPr>
+            </a:pPr>
+            <a:r>
+              <a:t>• Polluted Comments: </a:t>
+            </a:r>
+          </a:p>
+          <a:p>
+            <a:pPr>
+              <a:defRPr sz="1050">
+                <a:solidFill>
+                  <a:srgbClr val="64748B"/>
+                </a:solidFill>
+              </a:defRPr>
+            </a:pPr>
+            <a:r>
+              <a:t>Many comments contain spam links, fake follower ads, and abusive hate speech targeting creators.</a:t>
+            </a:r>
+          </a:p>
+          <a:p>
+            <a:pPr>
+              <a:spcBef>
+                <a:spcPts val="600"/>
+              </a:spcBef>
+              <a:defRPr b="1" sz="1100">
+                <a:solidFill>
+                  <a:srgbClr val="0F172A"/>
+                </a:solidFill>
+              </a:defRPr>
+            </a:pPr>
+            <a:r>
+              <a:t>• The Human Bottleneck: </a:t>
+            </a:r>
+          </a:p>
+          <a:p>
+            <a:pPr>
+              <a:defRPr sz="1050">
+                <a:solidFill>
+                  <a:srgbClr val="64748B"/>
+                </a:solidFill>
+              </a:defRPr>
+            </a:pPr>
+            <a:r>
+              <a:t>There are only 2 human moderators. Two people can realistically review at most ~1,000 comments/day.</a:t>
+            </a:r>
+          </a:p>
+          <a:p>
+            <a:pPr>
+              <a:spcBef>
+                <a:spcPts val="600"/>
+              </a:spcBef>
+              <a:defRPr b="1" sz="1100">
+                <a:solidFill>
+                  <a:srgbClr val="0F172A"/>
+                </a:solidFill>
+              </a:defRPr>
+            </a:pPr>
+            <a:r>
+              <a:t>• The Core Dilemma: </a:t>
+            </a:r>
+          </a:p>
+          <a:p>
+            <a:pPr>
+              <a:defRPr sz="1050">
+                <a:solidFill>
+                  <a:srgbClr val="64748B"/>
+                </a:solidFill>
+              </a:defRPr>
+            </a:pPr>
+            <a:r>
+              <a:t>Manual review of 20,000 comments is impossible. We need AI to automate the safe &amp; bad, and send only the unclear ones to humans.</a:t>
             </a:r>
           </a:p>
         </p:txBody>
@@ -3300,8 +4210,8 @@
         </p:nvSpPr>
         <p:spPr>
           <a:xfrm>
-            <a:off x="4343400" y="2926080"/>
-            <a:ext cx="3429000" cy="3200400"/>
+            <a:off x="6217920" y="2651760"/>
+            <a:ext cx="5212080" cy="3566160"/>
           </a:xfrm>
           <a:prstGeom prst="roundRect">
             <a:avLst/>
@@ -3345,8 +4255,8 @@
         </p:nvSpPr>
         <p:spPr>
           <a:xfrm>
-            <a:off x="4617720" y="3200400"/>
-            <a:ext cx="2880360" cy="2651760"/>
+            <a:off x="6446520" y="2834640"/>
+            <a:ext cx="4754880" cy="3200400"/>
           </a:xfrm>
           <a:prstGeom prst="rect">
             <a:avLst/>
@@ -3362,130 +4272,120 @@
             <a:pPr>
               <a:defRPr sz="1600" b="1">
                 <a:solidFill>
-                  <a:srgbClr val="0F172A"/>
-                </a:solidFill>
-              </a:defRPr>
-            </a:pPr>
-            <a:r>
-              <a:t>The Human Bottleneck</a:t>
+                  <a:srgbClr val="059669"/>
+                </a:solidFill>
+              </a:defRPr>
+            </a:pPr>
+            <a:r>
+              <a:t>The Proposed Solution (In Simple Words)</a:t>
             </a:r>
           </a:p>
           <a:p>
             <a:pPr>
               <a:spcBef>
-                <a:spcPts val="1000"/>
+                <a:spcPts val="600"/>
               </a:spcBef>
-              <a:defRPr sz="1200">
+              <a:defRPr b="1" sz="1100">
+                <a:solidFill>
+                  <a:srgbClr val="0F172A"/>
+                </a:solidFill>
+              </a:defRPr>
+            </a:pPr>
+            <a:r>
+              <a:t>• 3-Tier AI Cascade: </a:t>
+            </a:r>
+          </a:p>
+          <a:p>
+            <a:pPr>
+              <a:defRPr sz="1050">
                 <a:solidFill>
                   <a:srgbClr val="64748B"/>
                 </a:solidFill>
               </a:defRPr>
             </a:pPr>
             <a:r>
-              <a:t>Only 2 human moderators available.</a:t>
-            </a:r>
-            <a:br/>
-            <a:r>
-              <a:t>Realistically, 2 people can only review ~1,000 to 1,500 items daily. Manual review is impossible.</a:t>
-            </a:r>
-          </a:p>
-        </p:txBody>
-      </p:sp>
-      <p:sp>
-        <p:nvSpPr>
-          <p:cNvPr id="8" name="Rounded Rectangle 7"/>
-          <p:cNvSpPr/>
-          <p:nvPr/>
-        </p:nvSpPr>
-        <p:spPr>
-          <a:xfrm>
-            <a:off x="7955280" y="2926080"/>
-            <a:ext cx="3429000" cy="3200400"/>
-          </a:xfrm>
-          <a:prstGeom prst="roundRect">
-            <a:avLst/>
-          </a:prstGeom>
-          <a:solidFill>
-            <a:srgbClr val="FFFFFF"/>
-          </a:solidFill>
-          <a:ln w="19050">
-            <a:solidFill>
-              <a:srgbClr val="E2E8F0"/>
-            </a:solidFill>
-          </a:ln>
-        </p:spPr>
-        <p:style>
-          <a:lnRef idx="1">
-            <a:schemeClr val="accent1"/>
-          </a:lnRef>
-          <a:fillRef idx="3">
-            <a:schemeClr val="accent1"/>
-          </a:fillRef>
-          <a:effectRef idx="2">
-            <a:schemeClr val="accent1"/>
-          </a:effectRef>
-          <a:fontRef idx="minor">
-            <a:schemeClr val="lt1"/>
-          </a:fontRef>
-        </p:style>
-        <p:txBody>
-          <a:bodyPr rtlCol="0" anchor="ctr"/>
-          <a:lstStyle/>
-          <a:p>
-            <a:pPr algn="ctr"/>
-          </a:p>
-        </p:txBody>
-      </p:sp>
-      <p:sp>
-        <p:nvSpPr>
-          <p:cNvPr id="9" name="TextBox 8"/>
-          <p:cNvSpPr txBox="1"/>
-          <p:nvPr/>
-        </p:nvSpPr>
-        <p:spPr>
-          <a:xfrm>
-            <a:off x="8229600" y="3200400"/>
-            <a:ext cx="2880360" cy="2651760"/>
-          </a:xfrm>
-          <a:prstGeom prst="rect">
-            <a:avLst/>
-          </a:prstGeom>
-          <a:noFill/>
-        </p:spPr>
-        <p:txBody>
-          <a:bodyPr wrap="square">
-            <a:spAutoFit/>
-          </a:bodyPr>
-          <a:lstStyle/>
-          <a:p>
-            <a:pPr>
-              <a:defRPr sz="1600" b="1">
-                <a:solidFill>
-                  <a:srgbClr val="0F172A"/>
-                </a:solidFill>
-              </a:defRPr>
-            </a:pPr>
-            <a:r>
-              <a:t>The Solution Strategy</a:t>
+              <a:t>Instead of using one heavy model, we chain 3 smart filters: Rules -&gt; Fast Machine Learning -&gt; Small Deep Learning.</a:t>
             </a:r>
           </a:p>
           <a:p>
             <a:pPr>
               <a:spcBef>
-                <a:spcPts val="1000"/>
+                <a:spcPts val="600"/>
               </a:spcBef>
-              <a:defRPr sz="1200">
+              <a:defRPr b="1" sz="1100">
+                <a:solidFill>
+                  <a:srgbClr val="0F172A"/>
+                </a:solidFill>
+              </a:defRPr>
+            </a:pPr>
+            <a:r>
+              <a:t>• 94% Automated Action: </a:t>
+            </a:r>
+          </a:p>
+          <a:p>
+            <a:pPr>
+              <a:defRPr sz="1050">
                 <a:solidFill>
                   <a:srgbClr val="64748B"/>
                 </a:solidFill>
               </a:defRPr>
             </a:pPr>
             <a:r>
-              <a:t>Cascaded 3-tier system: AI Rules -&gt; Classical ML -&gt; Small Transformer.</a:t>
-            </a:r>
-            <a:br/>
-            <a:r>
-              <a:t>AI auto-processes 94%; only ~320 borderline cases reach the 2 moderators.</a:t>
+              <a:t>18,800 comments are handled automatically: safe comments publish instantly, and obvious spam/slurs are hidden.</a:t>
+            </a:r>
+          </a:p>
+          <a:p>
+            <a:pPr>
+              <a:spcBef>
+                <a:spcPts val="600"/>
+              </a:spcBef>
+              <a:defRPr b="1" sz="1100">
+                <a:solidFill>
+                  <a:srgbClr val="0F172A"/>
+                </a:solidFill>
+              </a:defRPr>
+            </a:pPr>
+            <a:r>
+              <a:t>• Manageable Human Queue: </a:t>
+            </a:r>
+          </a:p>
+          <a:p>
+            <a:pPr>
+              <a:defRPr sz="1050">
+                <a:solidFill>
+                  <a:srgbClr val="64748B"/>
+                </a:solidFill>
+              </a:defRPr>
+            </a:pPr>
+            <a:r>
+              <a:t>Only ~320 borderline/unclear comments reach the 2 moderators (~160 each, taking under 45 minutes daily).</a:t>
+            </a:r>
+          </a:p>
+          <a:p>
+            <a:pPr>
+              <a:spcBef>
+                <a:spcPts val="600"/>
+              </a:spcBef>
+              <a:defRPr b="1" sz="1100">
+                <a:solidFill>
+                  <a:srgbClr val="0F172A"/>
+                </a:solidFill>
+              </a:defRPr>
+            </a:pPr>
+            <a:r>
+              <a:t>• Active Learning Loop: </a:t>
+            </a:r>
+          </a:p>
+          <a:p>
+            <a:pPr>
+              <a:defRPr sz="1050">
+                <a:solidFill>
+                  <a:srgbClr val="64748B"/>
+                </a:solidFill>
+              </a:defRPr>
+            </a:pPr>
+            <a:r>
+              <a:t>Every decision made by the 2 moderators feeds back into weekly retraining so the AI continuously learns new tricks.</a:t>
             </a:r>
           </a:p>
         </p:txBody>
@@ -3559,8 +4459,8 @@
         </p:nvSpPr>
         <p:spPr>
           <a:xfrm>
-            <a:off x="731520" y="457200"/>
-            <a:ext cx="10728655" cy="1005840"/>
+            <a:off x="731520" y="411480"/>
+            <a:ext cx="10728655" cy="1051560"/>
           </a:xfrm>
           <a:prstGeom prst="rect">
             <a:avLst/>
@@ -3574,26 +4474,26 @@
           <a:lstStyle/>
           <a:p>
             <a:pPr>
-              <a:defRPr sz="1100" b="1">
+              <a:defRPr sz="1050" b="1">
                 <a:solidFill>
                   <a:srgbClr val="D97706"/>
                 </a:solidFill>
               </a:defRPr>
             </a:pPr>
             <a:r>
-              <a:t>ITC INFOTECH · EMINENCE CAMPUS DRIVE | SYSTEM ARCHITECTURE</a:t>
+              <a:t>ITC INFOTECH · EMINENCE CAMPUS DRIVE 2026 | SYSTEM ARCHITECTURE &amp; FLOW</a:t>
             </a:r>
           </a:p>
           <a:p>
             <a:pPr>
-              <a:defRPr sz="2400" b="1">
+              <a:defRPr sz="2300" b="1">
                 <a:solidFill>
                   <a:srgbClr val="0F172A"/>
                 </a:solidFill>
               </a:defRPr>
             </a:pPr>
             <a:r>
-              <a:t>The 3-Tier Cascade Architecture: AI ⊃ ML ⊃ DL</a:t>
+              <a:t>The 3-Tier Cascade Architecture (AI ⊃ ML ⊃ DL)</a:t>
             </a:r>
           </a:p>
         </p:txBody>
@@ -3606,8 +4506,8 @@
         </p:nvSpPr>
         <p:spPr>
           <a:xfrm>
-            <a:off x="731520" y="1645920"/>
-            <a:ext cx="2560320" cy="4480560"/>
+            <a:off x="731520" y="1600200"/>
+            <a:ext cx="10728655" cy="594360"/>
           </a:xfrm>
           <a:prstGeom prst="roundRect">
             <a:avLst/>
@@ -3615,7 +4515,7 @@
           <a:solidFill>
             <a:srgbClr val="FFFFFF"/>
           </a:solidFill>
-          <a:ln w="19050">
+          <a:ln>
             <a:solidFill>
               <a:srgbClr val="E2E8F0"/>
             </a:solidFill>
@@ -3651,8 +4551,8 @@
         </p:nvSpPr>
         <p:spPr>
           <a:xfrm>
-            <a:off x="914400" y="1874520"/>
-            <a:ext cx="2194560" cy="4023360"/>
+            <a:off x="822960" y="1645920"/>
+            <a:ext cx="10515600" cy="502920"/>
           </a:xfrm>
           <a:prstGeom prst="rect">
             <a:avLst/>
@@ -3666,53 +4566,14 @@
           <a:lstStyle/>
           <a:p>
             <a:pPr>
-              <a:defRPr sz="1300" b="1">
+              <a:defRPr sz="1100" b="1">
                 <a:solidFill>
                   <a:srgbClr val="0F172A"/>
                 </a:solidFill>
               </a:defRPr>
             </a:pPr>
             <a:r>
-              <a:t>Layer 1: Deterministic AI Rules</a:t>
-            </a:r>
-          </a:p>
-          <a:p>
-            <a:pPr>
-              <a:defRPr sz="1000" b="1">
-                <a:solidFill>
-                  <a:srgbClr val="64748B"/>
-                </a:solidFill>
-              </a:defRPr>
-            </a:pPr>
-            <a:r>
-              <a:t>Obvious Filters (~1ms latency)</a:t>
-            </a:r>
-          </a:p>
-          <a:p>
-            <a:pPr>
-              <a:spcBef>
-                <a:spcPts val="1000"/>
-              </a:spcBef>
-              <a:defRPr sz="1000">
-                <a:solidFill>
-                  <a:srgbClr val="0F172A"/>
-                </a:solidFill>
-              </a:defRPr>
-            </a:pPr>
-            <a:r>
-              <a:t>• Regex for shorteners (bit.ly, t.me), telegram handles, and phone numbers.</a:t>
-            </a:r>
-            <a:br/>
-            <a:r>
-              <a:t>• Known spam domain blacklists and severe hate speech blocklists.</a:t>
-            </a:r>
-            <a:br/>
-            <a:r>
-              <a:t>• Cooking domain allowlist protects culinary verbs ('beat', 'kill the heat').</a:t>
-            </a:r>
-            <a:br/>
-            <a:r>
-              <a:t>• Catches 50-60% of obvious traffic at zero compute cost.</a:t>
+              <a:t>⚡ Incoming Comment (20k/day)  →  Tier 1: Rules (1ms)  →  Tier 2: ML (5ms)  →  Tier 3: DistilBERT (14ms)  →  2 Human Moderators (320/day)</a:t>
             </a:r>
           </a:p>
         </p:txBody>
@@ -3725,8 +4586,8 @@
         </p:nvSpPr>
         <p:spPr>
           <a:xfrm>
-            <a:off x="3429000" y="1645920"/>
-            <a:ext cx="2560320" cy="4480560"/>
+            <a:off x="731520" y="2377440"/>
+            <a:ext cx="2560320" cy="4114800"/>
           </a:xfrm>
           <a:prstGeom prst="roundRect">
             <a:avLst/>
@@ -3736,7 +4597,7 @@
           </a:solidFill>
           <a:ln w="19050">
             <a:solidFill>
-              <a:srgbClr val="E2E8F0"/>
+              <a:srgbClr val="0F172A"/>
             </a:solidFill>
           </a:ln>
         </p:spPr>
@@ -3770,8 +4631,8 @@
         </p:nvSpPr>
         <p:spPr>
           <a:xfrm>
-            <a:off x="3611880" y="1874520"/>
-            <a:ext cx="2194560" cy="4023360"/>
+            <a:off x="914400" y="2560320"/>
+            <a:ext cx="2194560" cy="3749040"/>
           </a:xfrm>
           <a:prstGeom prst="rect">
             <a:avLst/>
@@ -3785,53 +4646,68 @@
           <a:lstStyle/>
           <a:p>
             <a:pPr>
-              <a:defRPr sz="1300" b="1">
-                <a:solidFill>
-                  <a:srgbClr val="D97706"/>
-                </a:solidFill>
-              </a:defRPr>
-            </a:pPr>
-            <a:r>
-              <a:t>Layer 2: Classical Machine Learning</a:t>
+              <a:defRPr sz="1200" b="1">
+                <a:solidFill>
+                  <a:srgbClr val="0F172A"/>
+                </a:solidFill>
+              </a:defRPr>
+            </a:pPr>
+            <a:r>
+              <a:t>Tier 1: Deterministic AI Rules</a:t>
             </a:r>
           </a:p>
           <a:p>
             <a:pPr>
-              <a:defRPr sz="1000" b="1">
+              <a:defRPr sz="950" b="1">
                 <a:solidFill>
                   <a:srgbClr val="64748B"/>
                 </a:solidFill>
               </a:defRPr>
             </a:pPr>
             <a:r>
-              <a:t>Probabilistic Scoring (~4ms latency)</a:t>
+              <a:t>Classic AI (No Learning)</a:t>
             </a:r>
           </a:p>
           <a:p>
             <a:pPr>
               <a:spcBef>
-                <a:spcPts val="1000"/>
+                <a:spcPts val="800"/>
               </a:spcBef>
-              <a:defRPr sz="1000">
+              <a:defRPr sz="950">
                 <a:solidFill>
                   <a:srgbClr val="0F172A"/>
                 </a:solidFill>
               </a:defRPr>
             </a:pPr>
             <a:r>
-              <a:t>• Feature extraction: TF-IDF, character n-grams, caps ratio, link counts.</a:t>
+              <a:t>Fast frontline sieve catching obvious patterns.</a:t>
             </a:r>
             <a:br/>
-            <a:r>
-              <a:t>• Lightweight classifier: Logistic Regression / Naive Bayes.</a:t>
-            </a:r>
             <a:br/>
             <a:r>
-              <a:t>• Computes prior probabilities: P(fine), P(spam), P(abusive).</a:t>
+              <a:t>Usage:</a:t>
             </a:r>
             <a:br/>
             <a:r>
-              <a:t>• Fast workhorse handling bulk classification with full explainability.</a:t>
+              <a:t>Scans for redirect links, promotional phone numbers, and slur blocklists. Also holds a culinary allowlist ('beat eggs', 'kill heat').</a:t>
+            </a:r>
+            <a:br/>
+            <a:br/>
+            <a:r>
+              <a:t>Concrete Example:</a:t>
+            </a:r>
+            <a:br/>
+            <a:r>
+              <a:t>'Win a free iPhone! bit.ly/knife-gift' -&gt; Matched URL regex -&gt; Auto-Hidden instantly.</a:t>
+            </a:r>
+            <a:br/>
+            <a:br/>
+            <a:r>
+              <a:t>Key Words:</a:t>
+            </a:r>
+            <a:br/>
+            <a:r>
+              <a:t>Regex, Blocklists, Obvious Sieve, ~1.2ms Latency, 50-60% Volume, Free Compute.</a:t>
             </a:r>
           </a:p>
         </p:txBody>
@@ -3844,8 +4720,8 @@
         </p:nvSpPr>
         <p:spPr>
           <a:xfrm>
-            <a:off x="6126480" y="1645920"/>
-            <a:ext cx="2560320" cy="4480560"/>
+            <a:off x="3429000" y="2377440"/>
+            <a:ext cx="2560320" cy="4114800"/>
           </a:xfrm>
           <a:prstGeom prst="roundRect">
             <a:avLst/>
@@ -3855,7 +4731,7 @@
           </a:solidFill>
           <a:ln w="19050">
             <a:solidFill>
-              <a:srgbClr val="E2E8F0"/>
+              <a:srgbClr val="D97706"/>
             </a:solidFill>
           </a:ln>
         </p:spPr>
@@ -3889,8 +4765,8 @@
         </p:nvSpPr>
         <p:spPr>
           <a:xfrm>
-            <a:off x="6309360" y="1874520"/>
-            <a:ext cx="2194560" cy="4023360"/>
+            <a:off x="3611880" y="2560320"/>
+            <a:ext cx="2194560" cy="3749040"/>
           </a:xfrm>
           <a:prstGeom prst="rect">
             <a:avLst/>
@@ -3904,53 +4780,68 @@
           <a:lstStyle/>
           <a:p>
             <a:pPr>
-              <a:defRPr sz="1300" b="1">
-                <a:solidFill>
-                  <a:srgbClr val="059669"/>
-                </a:solidFill>
-              </a:defRPr>
-            </a:pPr>
-            <a:r>
-              <a:t>Layer 3: Small Transformer (DistilBERT)</a:t>
+              <a:defRPr sz="1200" b="1">
+                <a:solidFill>
+                  <a:srgbClr val="D97706"/>
+                </a:solidFill>
+              </a:defRPr>
+            </a:pPr>
+            <a:r>
+              <a:t>Tier 2: Classical Machine Learning</a:t>
             </a:r>
           </a:p>
           <a:p>
             <a:pPr>
-              <a:defRPr sz="1000" b="1">
+              <a:defRPr sz="950" b="1">
                 <a:solidFill>
                   <a:srgbClr val="64748B"/>
                 </a:solidFill>
               </a:defRPr>
             </a:pPr>
             <a:r>
-              <a:t>Context &amp; Nuance (~14ms CPU)</a:t>
+              <a:t>Statistical Feature Scoring</a:t>
             </a:r>
           </a:p>
           <a:p>
             <a:pPr>
               <a:spcBef>
-                <a:spcPts val="1000"/>
+                <a:spcPts val="800"/>
               </a:spcBef>
-              <a:defRPr sz="1000">
+              <a:defRPr sz="950">
                 <a:solidFill>
                   <a:srgbClr val="0F172A"/>
                 </a:solidFill>
               </a:defRPr>
             </a:pPr>
             <a:r>
-              <a:t>• Fine-tuned 66M parameter DistilBERT model (NOT a bulky LLM).</a:t>
+              <a:t>Probabilistic workhorse handling bulk text.</a:t>
             </a:r>
             <a:br/>
-            <a:r>
-              <a:t>• Understands sentence structure, sentiment, and cooking slang.</a:t>
-            </a:r>
             <a:br/>
             <a:r>
-              <a:t>• Resolves ambiguous cases: 'killer recipe' (praise) vs. hostile threats.</a:t>
+              <a:t>Usage:</a:t>
             </a:r>
             <a:br/>
             <a:r>
-              <a:t>• Evaluates ONLY the remaining borderline cases (~15-20% of traffic).</a:t>
+              <a:t>Extracts text features: shouting caps ratio, punctuation intensity, and TF-IDF word n-grams with Logistic Regression.</a:t>
+            </a:r>
+            <a:br/>
+            <a:br/>
+            <a:r>
+              <a:t>Concrete Example:</a:t>
+            </a:r>
+            <a:br/>
+            <a:r>
+              <a:t>'DM ME FOR CHEAP FOLLOWERS NOW!!!!' -&gt; High caps + promo tokens -&gt; ML Spam Prior 94%.</a:t>
+            </a:r>
+            <a:br/>
+            <a:br/>
+            <a:r>
+              <a:t>Key Words:</a:t>
+            </a:r>
+            <a:br/>
+            <a:r>
+              <a:t>TF-IDF, Caps Ratio, Logistic Regression, Prior Probability, ~4.8ms Latency.</a:t>
             </a:r>
           </a:p>
         </p:txBody>
@@ -3963,8 +4854,8 @@
         </p:nvSpPr>
         <p:spPr>
           <a:xfrm>
-            <a:off x="8823960" y="1645920"/>
-            <a:ext cx="2560320" cy="4480560"/>
+            <a:off x="6126480" y="2377440"/>
+            <a:ext cx="2560320" cy="4114800"/>
           </a:xfrm>
           <a:prstGeom prst="roundRect">
             <a:avLst/>
@@ -3974,7 +4865,7 @@
           </a:solidFill>
           <a:ln w="19050">
             <a:solidFill>
-              <a:srgbClr val="E2E8F0"/>
+              <a:srgbClr val="059669"/>
             </a:solidFill>
           </a:ln>
         </p:spPr>
@@ -4008,8 +4899,8 @@
         </p:nvSpPr>
         <p:spPr>
           <a:xfrm>
-            <a:off x="9006840" y="1874520"/>
-            <a:ext cx="2194560" cy="4023360"/>
+            <a:off x="6309360" y="2560320"/>
+            <a:ext cx="2194560" cy="3749040"/>
           </a:xfrm>
           <a:prstGeom prst="rect">
             <a:avLst/>
@@ -4023,53 +4914,202 @@
           <a:lstStyle/>
           <a:p>
             <a:pPr>
-              <a:defRPr sz="1300" b="1">
-                <a:solidFill>
-                  <a:srgbClr val="2563EB"/>
-                </a:solidFill>
-              </a:defRPr>
-            </a:pPr>
-            <a:r>
-              <a:t>Layer 4: Human-in-the-Loop Safeguard</a:t>
+              <a:defRPr sz="1200" b="1">
+                <a:solidFill>
+                  <a:srgbClr val="059669"/>
+                </a:solidFill>
+              </a:defRPr>
+            </a:pPr>
+            <a:r>
+              <a:t>Tier 3: Small Transformer</a:t>
             </a:r>
           </a:p>
           <a:p>
             <a:pPr>
-              <a:defRPr sz="1000" b="1">
+              <a:defRPr sz="950" b="1">
                 <a:solidFill>
                   <a:srgbClr val="64748B"/>
                 </a:solidFill>
               </a:defRPr>
             </a:pPr>
             <a:r>
-              <a:t>2 Moderators (~320 cases/day)</a:t>
+              <a:t>DistilBERT Semantic Context</a:t>
             </a:r>
           </a:p>
           <a:p>
             <a:pPr>
               <a:spcBef>
-                <a:spcPts val="1000"/>
+                <a:spcPts val="800"/>
               </a:spcBef>
-              <a:defRPr sz="1000">
+              <a:defRPr sz="950">
                 <a:solidFill>
                   <a:srgbClr val="0F172A"/>
                 </a:solidFill>
               </a:defRPr>
             </a:pPr>
             <a:r>
-              <a:t>• Evaluates uncertain comments where confidence is 40% - 89%.</a:t>
+              <a:t>Deep language understanding specialist.</a:t>
             </a:r>
             <a:br/>
-            <a:r>
-              <a:t>• Moderators review a manageable backlog of ~160 comments each.</a:t>
-            </a:r>
             <a:br/>
             <a:r>
-              <a:t>• Every human decision generates a fresh active learning label.</a:t>
+              <a:t>Usage:</a:t>
             </a:r>
             <a:br/>
             <a:r>
-              <a:t>• Drives weekly model retraining and threshold recalibration.</a:t>
+              <a:t>Evaluates full sentence context and slang. Specifically resolves cooking idioms so genuine compliments are never hidden.</a:t>
+            </a:r>
+            <a:br/>
+            <a:br/>
+            <a:r>
+              <a:t>Concrete Example:</a:t>
+            </a:r>
+            <a:br/>
+            <a:r>
+              <a:t>'This recipe is killer, I would die for this risotto!' -&gt; Context acclaim -&gt; Auto-Published (98%).</a:t>
+            </a:r>
+            <a:br/>
+            <a:br/>
+            <a:r>
+              <a:t>Key Words:</a:t>
+            </a:r>
+            <a:br/>
+            <a:r>
+              <a:t>DistilBERT (66M params), Context Attention, ~14.5ms CPU, Cooking Nuance.</a:t>
+            </a:r>
+          </a:p>
+        </p:txBody>
+      </p:sp>
+      <p:sp>
+        <p:nvSpPr>
+          <p:cNvPr id="12" name="Rounded Rectangle 11"/>
+          <p:cNvSpPr/>
+          <p:nvPr/>
+        </p:nvSpPr>
+        <p:spPr>
+          <a:xfrm>
+            <a:off x="8823960" y="2377440"/>
+            <a:ext cx="2560320" cy="4114800"/>
+          </a:xfrm>
+          <a:prstGeom prst="roundRect">
+            <a:avLst/>
+          </a:prstGeom>
+          <a:solidFill>
+            <a:srgbClr val="FFFFFF"/>
+          </a:solidFill>
+          <a:ln w="19050">
+            <a:solidFill>
+              <a:srgbClr val="2563EB"/>
+            </a:solidFill>
+          </a:ln>
+        </p:spPr>
+        <p:style>
+          <a:lnRef idx="1">
+            <a:schemeClr val="accent1"/>
+          </a:lnRef>
+          <a:fillRef idx="3">
+            <a:schemeClr val="accent1"/>
+          </a:fillRef>
+          <a:effectRef idx="2">
+            <a:schemeClr val="accent1"/>
+          </a:effectRef>
+          <a:fontRef idx="minor">
+            <a:schemeClr val="lt1"/>
+          </a:fontRef>
+        </p:style>
+        <p:txBody>
+          <a:bodyPr rtlCol="0" anchor="ctr"/>
+          <a:lstStyle/>
+          <a:p>
+            <a:pPr algn="ctr"/>
+          </a:p>
+        </p:txBody>
+      </p:sp>
+      <p:sp>
+        <p:nvSpPr>
+          <p:cNvPr id="13" name="TextBox 12"/>
+          <p:cNvSpPr txBox="1"/>
+          <p:nvPr/>
+        </p:nvSpPr>
+        <p:spPr>
+          <a:xfrm>
+            <a:off x="9006840" y="2560320"/>
+            <a:ext cx="2194560" cy="3749040"/>
+          </a:xfrm>
+          <a:prstGeom prst="rect">
+            <a:avLst/>
+          </a:prstGeom>
+          <a:noFill/>
+        </p:spPr>
+        <p:txBody>
+          <a:bodyPr wrap="square">
+            <a:spAutoFit/>
+          </a:bodyPr>
+          <a:lstStyle/>
+          <a:p>
+            <a:pPr>
+              <a:defRPr sz="1200" b="1">
+                <a:solidFill>
+                  <a:srgbClr val="2563EB"/>
+                </a:solidFill>
+              </a:defRPr>
+            </a:pPr>
+            <a:r>
+              <a:t>Tier 4: Human-in-the-Loop</a:t>
+            </a:r>
+          </a:p>
+          <a:p>
+            <a:pPr>
+              <a:defRPr sz="950" b="1">
+                <a:solidFill>
+                  <a:srgbClr val="64748B"/>
+                </a:solidFill>
+              </a:defRPr>
+            </a:pPr>
+            <a:r>
+              <a:t>2 Moderators (~320 cases/day)</a:t>
+            </a:r>
+          </a:p>
+          <a:p>
+            <a:pPr>
+              <a:spcBef>
+                <a:spcPts val="800"/>
+              </a:spcBef>
+              <a:defRPr sz="950">
+                <a:solidFill>
+                  <a:srgbClr val="0F172A"/>
+                </a:solidFill>
+              </a:defRPr>
+            </a:pPr>
+            <a:r>
+              <a:t>The final safety net for genuine ambiguity.</a:t>
+            </a:r>
+            <a:br/>
+            <a:br/>
+            <a:r>
+              <a:t>Usage:</a:t>
+            </a:r>
+            <a:br/>
+            <a:r>
+              <a:t>Reviews comments where AI confidence is between 40% and 89%. Top ~160 cases per moderator daily.</a:t>
+            </a:r>
+            <a:br/>
+            <a:br/>
+            <a:r>
+              <a:t>Concrete Example:</a:t>
+            </a:r>
+            <a:br/>
+            <a:r>
+              <a:t>'This timing seems weird... not sure about step 2' -&gt; Ambiguous sentiment -&gt; Human verifies.</a:t>
+            </a:r>
+            <a:br/>
+            <a:br/>
+            <a:r>
+              <a:t>Key Words:</a:t>
+            </a:r>
+            <a:br/>
+            <a:r>
+              <a:t>Human-in-the-Loop, Active Learning, Labeled Dataset, Weekly Retraining.</a:t>
             </a:r>
           </a:p>
         </p:txBody>
@@ -4143,8 +5183,8 @@
         </p:nvSpPr>
         <p:spPr>
           <a:xfrm>
-            <a:off x="731520" y="457200"/>
-            <a:ext cx="10728655" cy="1005840"/>
+            <a:off x="731520" y="411480"/>
+            <a:ext cx="10728655" cy="1051560"/>
           </a:xfrm>
           <a:prstGeom prst="rect">
             <a:avLst/>
@@ -4158,26 +5198,26 @@
           <a:lstStyle/>
           <a:p>
             <a:pPr>
-              <a:defRPr sz="1100" b="1">
+              <a:defRPr sz="1050" b="1">
                 <a:solidFill>
                   <a:srgbClr val="D97706"/>
                 </a:solidFill>
               </a:defRPr>
             </a:pPr>
             <a:r>
-              <a:t>ITC INFOTECH · EMINENCE CAMPUS DRIVE | QUESTION 1 &amp; 2</a:t>
+              <a:t>ITC INFOTECH · EMINENCE CAMPUS DRIVE 2026 | QUESTION 1 &amp; QUESTION 2</a:t>
             </a:r>
           </a:p>
           <a:p>
             <a:pPr>
-              <a:defRPr sz="2400" b="1">
+              <a:defRPr sz="2300" b="1">
                 <a:solidFill>
                   <a:srgbClr val="0F172A"/>
                 </a:solidFill>
               </a:defRPr>
             </a:pPr>
             <a:r>
-              <a:t>Classification Strategy &amp; Automated Action Policies</a:t>
+              <a:t>Classification Strategy &amp; Automated Action Workflows</a:t>
             </a:r>
           </a:p>
         </p:txBody>
@@ -4190,8 +5230,8 @@
         </p:nvSpPr>
         <p:spPr>
           <a:xfrm>
-            <a:off x="731520" y="1645920"/>
-            <a:ext cx="2560320" cy="4480560"/>
+            <a:off x="731520" y="1600200"/>
+            <a:ext cx="10728655" cy="2011680"/>
           </a:xfrm>
           <a:prstGeom prst="roundRect">
             <a:avLst/>
@@ -4199,7 +5239,118 @@
           <a:solidFill>
             <a:srgbClr val="FFFFFF"/>
           </a:solidFill>
-          <a:ln w="25400">
+          <a:ln w="19050">
+            <a:solidFill>
+              <a:srgbClr val="E2E8F0"/>
+            </a:solidFill>
+          </a:ln>
+        </p:spPr>
+        <p:style>
+          <a:lnRef idx="1">
+            <a:schemeClr val="accent1"/>
+          </a:lnRef>
+          <a:fillRef idx="3">
+            <a:schemeClr val="accent1"/>
+          </a:fillRef>
+          <a:effectRef idx="2">
+            <a:schemeClr val="accent1"/>
+          </a:effectRef>
+          <a:fontRef idx="minor">
+            <a:schemeClr val="lt1"/>
+          </a:fontRef>
+        </p:style>
+        <p:txBody>
+          <a:bodyPr rtlCol="0" anchor="ctr"/>
+          <a:lstStyle/>
+          <a:p>
+            <a:pPr algn="ctr"/>
+          </a:p>
+        </p:txBody>
+      </p:sp>
+      <p:sp>
+        <p:nvSpPr>
+          <p:cNvPr id="5" name="TextBox 4"/>
+          <p:cNvSpPr txBox="1"/>
+          <p:nvPr/>
+        </p:nvSpPr>
+        <p:spPr>
+          <a:xfrm>
+            <a:off x="960120" y="1737360"/>
+            <a:ext cx="10241280" cy="1737360"/>
+          </a:xfrm>
+          <a:prstGeom prst="rect">
+            <a:avLst/>
+          </a:prstGeom>
+          <a:noFill/>
+        </p:spPr>
+        <p:txBody>
+          <a:bodyPr wrap="square">
+            <a:spAutoFit/>
+          </a:bodyPr>
+          <a:lstStyle/>
+          <a:p>
+            <a:pPr>
+              <a:defRPr sz="1500" b="1">
+                <a:solidFill>
+                  <a:srgbClr val="0F172A"/>
+                </a:solidFill>
+              </a:defRPr>
+            </a:pPr>
+            <a:r>
+              <a:t>Question 1: How would you classify comments as Fine, Spam, Abusive, or Unclear?</a:t>
+            </a:r>
+          </a:p>
+          <a:p>
+            <a:pPr>
+              <a:spcBef>
+                <a:spcPts val="600"/>
+              </a:spcBef>
+              <a:defRPr sz="1050">
+                <a:solidFill>
+                  <a:srgbClr val="64748B"/>
+                </a:solidFill>
+              </a:defRPr>
+            </a:pPr>
+            <a:r>
+              <a:t>We use a multi-tiered scoring pipeline that produces calibrated class probabilities: P(fine), P(spam), and P(abusive). Classification is determined through calibrated confidence thresholds:</a:t>
+            </a:r>
+            <a:br/>
+            <a:r>
+              <a:t>• FINE: P(fine) ≥ 0.90 with zero rule violations (e.g., 'Can I use oat milk instead of regular milk?').</a:t>
+            </a:r>
+            <a:br/>
+            <a:r>
+              <a:t>• SPAM: P(spam) ≥ 0.90 or verified commercial link shortener (e.g., 'Click bit.ly/knife-deal now').</a:t>
+            </a:r>
+            <a:br/>
+            <a:r>
+              <a:t>• ABUSIVE: P(abusive) ≥ 0.90 with identified harassment intent (e.g., 'You're an idiot, nobody should listen to you').</a:t>
+            </a:r>
+            <a:br/>
+            <a:r>
+              <a:t>• UNCLEAR: Confidence falls between 0.40 and 0.89, or conflicting signals exist (e.g., 'Wow, genius idea...').</a:t>
+            </a:r>
+          </a:p>
+        </p:txBody>
+      </p:sp>
+      <p:sp>
+        <p:nvSpPr>
+          <p:cNvPr id="6" name="Rounded Rectangle 5"/>
+          <p:cNvSpPr/>
+          <p:nvPr/>
+        </p:nvSpPr>
+        <p:spPr>
+          <a:xfrm>
+            <a:off x="731520" y="3794760"/>
+            <a:ext cx="2560320" cy="2697480"/>
+          </a:xfrm>
+          <a:prstGeom prst="roundRect">
+            <a:avLst/>
+          </a:prstGeom>
+          <a:solidFill>
+            <a:srgbClr val="FFFFFF"/>
+          </a:solidFill>
+          <a:ln w="19050">
             <a:solidFill>
               <a:srgbClr val="059669"/>
             </a:solidFill>
@@ -4229,14 +5380,14 @@
       </p:sp>
       <p:sp>
         <p:nvSpPr>
-          <p:cNvPr id="5" name="TextBox 4"/>
+          <p:cNvPr id="7" name="TextBox 6"/>
           <p:cNvSpPr txBox="1"/>
           <p:nvPr/>
         </p:nvSpPr>
         <p:spPr>
           <a:xfrm>
-            <a:off x="960120" y="1874520"/>
-            <a:ext cx="2103120" cy="4023360"/>
+            <a:off x="896112" y="3959352"/>
+            <a:ext cx="2231136" cy="2368296"/>
           </a:xfrm>
           <a:prstGeom prst="rect">
             <a:avLst/>
@@ -4250,72 +5401,62 @@
           <a:lstStyle/>
           <a:p>
             <a:pPr>
-              <a:defRPr sz="1300" b="1">
+              <a:defRPr sz="1100" b="1">
                 <a:solidFill>
                   <a:srgbClr val="059669"/>
                 </a:solidFill>
               </a:defRPr>
             </a:pPr>
             <a:r>
-              <a:t>FINE COMMENTS (57%)</a:t>
-            </a:r>
-          </a:p>
-          <a:p>
-            <a:pPr>
-              <a:defRPr sz="1000" b="1">
-                <a:solidFill>
-                  <a:srgbClr val="64748B"/>
-                </a:solidFill>
-              </a:defRPr>
-            </a:pPr>
-            <a:r>
-              <a:t>Confidence ≥ 90%</a:t>
+              <a:t>FINE (57% · 11,400/day)</a:t>
             </a:r>
           </a:p>
           <a:p>
             <a:pPr>
               <a:spcBef>
-                <a:spcPts val="800"/>
+                <a:spcPts val="200"/>
               </a:spcBef>
-              <a:defRPr sz="1050">
+              <a:defRPr sz="1150" b="1">
                 <a:solidFill>
                   <a:srgbClr val="0F172A"/>
                 </a:solidFill>
               </a:defRPr>
             </a:pPr>
             <a:r>
-              <a:t>Definition:</a:t>
+              <a:t>Action: AUTO-PUBLISH</a:t>
+            </a:r>
+          </a:p>
+          <a:p>
+            <a:pPr>
+              <a:spcBef>
+                <a:spcPts val="600"/>
+              </a:spcBef>
+              <a:defRPr sz="950">
+                <a:solidFill>
+                  <a:srgbClr val="64748B"/>
+                </a:solidFill>
+              </a:defRPr>
+            </a:pPr>
+            <a:r>
+              <a:t>What Happens:</a:t>
             </a:r>
             <a:br/>
             <a:r>
-              <a:t>Constructive queries, recipe feedback, compliments ('Can I use oat milk?', 'Great recipe!').</a:t>
-            </a:r>
-            <a:br/>
-            <a:br/>
-            <a:r>
-              <a:t>Automated Action:</a:t>
-            </a:r>
-            <a:br/>
-            <a:r>
-              <a:t>AUTO-PUBLISH immediately.</a:t>
-            </a:r>
-            <a:br/>
-            <a:r>
-              <a:t>Visible to all users instantly; zero creator friction.</a:t>
-            </a:r>
-          </a:p>
-        </p:txBody>
-      </p:sp>
-      <p:sp>
-        <p:nvSpPr>
-          <p:cNvPr id="6" name="Rounded Rectangle 5"/>
+              <a:t>Comment is published immediately and visible on the video. Zero moderator intervention. Zero creator friction.</a:t>
+            </a:r>
+          </a:p>
+        </p:txBody>
+      </p:sp>
+      <p:sp>
+        <p:nvSpPr>
+          <p:cNvPr id="8" name="Rounded Rectangle 7"/>
           <p:cNvSpPr/>
           <p:nvPr/>
         </p:nvSpPr>
         <p:spPr>
           <a:xfrm>
-            <a:off x="3429000" y="1645920"/>
-            <a:ext cx="2560320" cy="4480560"/>
+            <a:off x="3429000" y="3794760"/>
+            <a:ext cx="2560320" cy="2697480"/>
           </a:xfrm>
           <a:prstGeom prst="roundRect">
             <a:avLst/>
@@ -4323,7 +5464,7 @@
           <a:solidFill>
             <a:srgbClr val="FFFFFF"/>
           </a:solidFill>
-          <a:ln w="25400">
+          <a:ln w="19050">
             <a:solidFill>
               <a:srgbClr val="D97706"/>
             </a:solidFill>
@@ -4353,14 +5494,14 @@
       </p:sp>
       <p:sp>
         <p:nvSpPr>
-          <p:cNvPr id="7" name="TextBox 6"/>
+          <p:cNvPr id="9" name="TextBox 8"/>
           <p:cNvSpPr txBox="1"/>
           <p:nvPr/>
         </p:nvSpPr>
         <p:spPr>
           <a:xfrm>
-            <a:off x="3657600" y="1874520"/>
-            <a:ext cx="2103120" cy="4023360"/>
+            <a:off x="3593592" y="3959352"/>
+            <a:ext cx="2231136" cy="2368296"/>
           </a:xfrm>
           <a:prstGeom prst="rect">
             <a:avLst/>
@@ -4374,72 +5515,62 @@
           <a:lstStyle/>
           <a:p>
             <a:pPr>
-              <a:defRPr sz="1300" b="1">
+              <a:defRPr sz="1100" b="1">
                 <a:solidFill>
                   <a:srgbClr val="D97706"/>
                 </a:solidFill>
               </a:defRPr>
             </a:pPr>
             <a:r>
-              <a:t>SPAM COMMENTS (21%)</a:t>
-            </a:r>
-          </a:p>
-          <a:p>
-            <a:pPr>
-              <a:defRPr sz="1000" b="1">
-                <a:solidFill>
-                  <a:srgbClr val="64748B"/>
-                </a:solidFill>
-              </a:defRPr>
-            </a:pPr>
-            <a:r>
-              <a:t>Confidence ≥ 90% or URL regex</a:t>
+              <a:t>SPAM (21% · 4,200/day)</a:t>
             </a:r>
           </a:p>
           <a:p>
             <a:pPr>
               <a:spcBef>
-                <a:spcPts val="800"/>
+                <a:spcPts val="200"/>
               </a:spcBef>
-              <a:defRPr sz="1050">
+              <a:defRPr sz="1150" b="1">
                 <a:solidFill>
                   <a:srgbClr val="0F172A"/>
                 </a:solidFill>
               </a:defRPr>
             </a:pPr>
             <a:r>
-              <a:t>Definition:</a:t>
+              <a:t>Action: AUTO-HIDE &amp; LOG</a:t>
+            </a:r>
+          </a:p>
+          <a:p>
+            <a:pPr>
+              <a:spcBef>
+                <a:spcPts val="600"/>
+              </a:spcBef>
+              <a:defRPr sz="950">
+                <a:solidFill>
+                  <a:srgbClr val="64748B"/>
+                </a:solidFill>
+              </a:defRPr>
+            </a:pPr>
+            <a:r>
+              <a:t>What Happens:</a:t>
             </a:r>
             <a:br/>
             <a:r>
-              <a:t>External redirect links (bit.ly), follower bots ('DM for promo'), financial scams.</a:t>
-            </a:r>
-            <a:br/>
-            <a:br/>
-            <a:r>
-              <a:t>Automated Action:</a:t>
-            </a:r>
-            <a:br/>
-            <a:r>
-              <a:t>AUTO-HIDE &amp; LOG.</a:t>
-            </a:r>
-            <a:br/>
-            <a:r>
-              <a:t>Hidden from public view; repeat offending accounts receive shadowbans or captchas.</a:t>
-            </a:r>
-          </a:p>
-        </p:txBody>
-      </p:sp>
-      <p:sp>
-        <p:nvSpPr>
-          <p:cNvPr id="8" name="Rounded Rectangle 7"/>
+              <a:t>Hidden from public view immediately. Offender logged; repeat offenses trigger temporary shadowbans or CAPTCHAs.</a:t>
+            </a:r>
+          </a:p>
+        </p:txBody>
+      </p:sp>
+      <p:sp>
+        <p:nvSpPr>
+          <p:cNvPr id="10" name="Rounded Rectangle 9"/>
           <p:cNvSpPr/>
           <p:nvPr/>
         </p:nvSpPr>
         <p:spPr>
           <a:xfrm>
-            <a:off x="6126480" y="1645920"/>
-            <a:ext cx="2560320" cy="4480560"/>
+            <a:off x="6126480" y="3794760"/>
+            <a:ext cx="2560320" cy="2697480"/>
           </a:xfrm>
           <a:prstGeom prst="roundRect">
             <a:avLst/>
@@ -4447,7 +5578,7 @@
           <a:solidFill>
             <a:srgbClr val="FFFFFF"/>
           </a:solidFill>
-          <a:ln w="25400">
+          <a:ln w="19050">
             <a:solidFill>
               <a:srgbClr val="E11D48"/>
             </a:solidFill>
@@ -4477,14 +5608,14 @@
       </p:sp>
       <p:sp>
         <p:nvSpPr>
-          <p:cNvPr id="9" name="TextBox 8"/>
+          <p:cNvPr id="11" name="TextBox 10"/>
           <p:cNvSpPr txBox="1"/>
           <p:nvPr/>
         </p:nvSpPr>
         <p:spPr>
           <a:xfrm>
-            <a:off x="6355080" y="1874520"/>
-            <a:ext cx="2103120" cy="4023360"/>
+            <a:off x="6291072" y="3959352"/>
+            <a:ext cx="2231136" cy="2368296"/>
           </a:xfrm>
           <a:prstGeom prst="rect">
             <a:avLst/>
@@ -4498,72 +5629,62 @@
           <a:lstStyle/>
           <a:p>
             <a:pPr>
-              <a:defRPr sz="1300" b="1">
+              <a:defRPr sz="1100" b="1">
                 <a:solidFill>
                   <a:srgbClr val="E11D48"/>
                 </a:solidFill>
               </a:defRPr>
             </a:pPr>
             <a:r>
-              <a:t>ABUSIVE COMMENTS (5%)</a:t>
-            </a:r>
-          </a:p>
-          <a:p>
-            <a:pPr>
-              <a:defRPr sz="1000" b="1">
-                <a:solidFill>
-                  <a:srgbClr val="64748B"/>
-                </a:solidFill>
-              </a:defRPr>
-            </a:pPr>
-            <a:r>
-              <a:t>Confidence ≥ 90% or slur match</a:t>
+              <a:t>ABUSIVE (5% · 900/day)</a:t>
             </a:r>
           </a:p>
           <a:p>
             <a:pPr>
               <a:spcBef>
-                <a:spcPts val="800"/>
+                <a:spcPts val="200"/>
               </a:spcBef>
-              <a:defRPr sz="1050">
+              <a:defRPr sz="1150" b="1">
                 <a:solidFill>
                   <a:srgbClr val="0F172A"/>
                 </a:solidFill>
               </a:defRPr>
             </a:pPr>
             <a:r>
-              <a:t>Definition:</a:t>
+              <a:t>Action: AUTO-HIDE &amp; POLICY FLAG</a:t>
+            </a:r>
+          </a:p>
+          <a:p>
+            <a:pPr>
+              <a:spcBef>
+                <a:spcPts val="600"/>
+              </a:spcBef>
+              <a:defRPr sz="950">
+                <a:solidFill>
+                  <a:srgbClr val="64748B"/>
+                </a:solidFill>
+              </a:defRPr>
+            </a:pPr>
+            <a:r>
+              <a:t>What Happens:</a:t>
             </a:r>
             <a:br/>
             <a:r>
-              <a:t>Direct ad-hominem harassment, hate speech, vulgarity targeting creators or users.</a:t>
-            </a:r>
-            <a:br/>
-            <a:br/>
-            <a:r>
-              <a:t>Automated Action:</a:t>
-            </a:r>
-            <a:br/>
-            <a:r>
-              <a:t>AUTO-HIDE &amp; POLICY FLAG.</a:t>
-            </a:r>
-            <a:br/>
-            <a:r>
-              <a:t>Hidden instantly; triggers safety strikes and temporary commenting cooldowns.</a:t>
-            </a:r>
-          </a:p>
-        </p:txBody>
-      </p:sp>
-      <p:sp>
-        <p:nvSpPr>
-          <p:cNvPr id="10" name="Rounded Rectangle 9"/>
+              <a:t>Hidden instantly. Account receives a community safety strike; severe toxicity triggers a commenting cooldown.</a:t>
+            </a:r>
+          </a:p>
+        </p:txBody>
+      </p:sp>
+      <p:sp>
+        <p:nvSpPr>
+          <p:cNvPr id="12" name="Rounded Rectangle 11"/>
           <p:cNvSpPr/>
           <p:nvPr/>
         </p:nvSpPr>
         <p:spPr>
           <a:xfrm>
-            <a:off x="8823960" y="1645920"/>
-            <a:ext cx="2560320" cy="4480560"/>
+            <a:off x="8823960" y="3794760"/>
+            <a:ext cx="2560320" cy="2697480"/>
           </a:xfrm>
           <a:prstGeom prst="roundRect">
             <a:avLst/>
@@ -4571,7 +5692,7 @@
           <a:solidFill>
             <a:srgbClr val="FFFFFF"/>
           </a:solidFill>
-          <a:ln w="25400">
+          <a:ln w="19050">
             <a:solidFill>
               <a:srgbClr val="2563EB"/>
             </a:solidFill>
@@ -4601,14 +5722,14 @@
       </p:sp>
       <p:sp>
         <p:nvSpPr>
-          <p:cNvPr id="11" name="TextBox 10"/>
+          <p:cNvPr id="13" name="TextBox 12"/>
           <p:cNvSpPr txBox="1"/>
           <p:nvPr/>
         </p:nvSpPr>
         <p:spPr>
           <a:xfrm>
-            <a:off x="9052560" y="1874520"/>
-            <a:ext cx="2103120" cy="4023360"/>
+            <a:off x="8988552" y="3959352"/>
+            <a:ext cx="2231136" cy="2368296"/>
           </a:xfrm>
           <a:prstGeom prst="rect">
             <a:avLst/>
@@ -4622,58 +5743,48 @@
           <a:lstStyle/>
           <a:p>
             <a:pPr>
-              <a:defRPr sz="1300" b="1">
+              <a:defRPr sz="1100" b="1">
                 <a:solidFill>
                   <a:srgbClr val="2563EB"/>
                 </a:solidFill>
               </a:defRPr>
             </a:pPr>
             <a:r>
-              <a:t>UNCLEAR / BORDERLINE (18%)</a:t>
-            </a:r>
-          </a:p>
-          <a:p>
-            <a:pPr>
-              <a:defRPr sz="1000" b="1">
-                <a:solidFill>
-                  <a:srgbClr val="64748B"/>
-                </a:solidFill>
-              </a:defRPr>
-            </a:pPr>
-            <a:r>
-              <a:t>Confidence 40% - 89%</a:t>
+              <a:t>UNCLEAR (18% · Top 320/day)</a:t>
             </a:r>
           </a:p>
           <a:p>
             <a:pPr>
               <a:spcBef>
-                <a:spcPts val="800"/>
+                <a:spcPts val="200"/>
               </a:spcBef>
-              <a:defRPr sz="1050">
+              <a:defRPr sz="1150" b="1">
                 <a:solidFill>
                   <a:srgbClr val="0F172A"/>
                 </a:solidFill>
               </a:defRPr>
             </a:pPr>
             <a:r>
-              <a:t>Definition:</a:t>
+              <a:t>Action: SEND TO HUMAN QUEUE</a:t>
+            </a:r>
+          </a:p>
+          <a:p>
+            <a:pPr>
+              <a:spcBef>
+                <a:spcPts val="600"/>
+              </a:spcBef>
+              <a:defRPr sz="950">
+                <a:solidFill>
+                  <a:srgbClr val="64748B"/>
+                </a:solidFill>
+              </a:defRPr>
+            </a:pPr>
+            <a:r>
+              <a:t>What Happens:</a:t>
             </a:r>
             <a:br/>
             <a:r>
-              <a:t>Sarcasm ('Wow, genius idea...'), vague links, mixed sentiment, or novel phrases.</a:t>
-            </a:r>
-            <a:br/>
-            <a:br/>
-            <a:r>
-              <a:t>Automated Action:</a:t>
-            </a:r>
-            <a:br/>
-            <a:r>
-              <a:t>ROUTE TO MODERATOR QUEUE.</a:t>
-            </a:r>
-            <a:br/>
-            <a:r>
-              <a:t>Prioritized by risk score. 2 moderators review the top ~320 borderline cases.</a:t>
+              <a:t>Queued for the 2 human moderators, prioritized by risk score. Resolving ~160 cases each takes under 45 mins daily.</a:t>
             </a:r>
           </a:p>
         </p:txBody>
@@ -4747,8 +5858,8 @@
         </p:nvSpPr>
         <p:spPr>
           <a:xfrm>
-            <a:off x="731520" y="457200"/>
-            <a:ext cx="10728655" cy="1005840"/>
+            <a:off x="731520" y="411480"/>
+            <a:ext cx="10728655" cy="1051560"/>
           </a:xfrm>
           <a:prstGeom prst="rect">
             <a:avLst/>
@@ -4762,26 +5873,26 @@
           <a:lstStyle/>
           <a:p>
             <a:pPr>
-              <a:defRPr sz="1100" b="1">
+              <a:defRPr sz="1050" b="1">
                 <a:solidFill>
                   <a:srgbClr val="D97706"/>
                 </a:solidFill>
               </a:defRPr>
             </a:pPr>
             <a:r>
-              <a:t>ITC INFOTECH · EMINENCE CAMPUS DRIVE | QUESTION 3 &amp; 4</a:t>
+              <a:t>ITC INFOTECH · EMINENCE CAMPUS DRIVE 2026 | QUESTION 3 &amp; QUESTION 4</a:t>
             </a:r>
           </a:p>
           <a:p>
             <a:pPr>
-              <a:defRPr sz="2400" b="1">
+              <a:defRPr sz="2300" b="1">
                 <a:solidFill>
                   <a:srgbClr val="0F172A"/>
                 </a:solidFill>
               </a:defRPr>
             </a:pPr>
             <a:r>
-              <a:t>Avoiding False Positives &amp; Continuous Learning</a:t>
+              <a:t>Avoiding False Hides &amp; Continuous Learning Loop</a:t>
             </a:r>
           </a:p>
         </p:txBody>
@@ -4795,7 +5906,7 @@
         <p:spPr>
           <a:xfrm>
             <a:off x="731520" y="1645920"/>
-            <a:ext cx="5212080" cy="4480560"/>
+            <a:ext cx="5212080" cy="4663440"/>
           </a:xfrm>
           <a:prstGeom prst="roundRect">
             <a:avLst/>
@@ -4839,8 +5950,8 @@
         </p:nvSpPr>
         <p:spPr>
           <a:xfrm>
-            <a:off x="1005840" y="1828800"/>
-            <a:ext cx="4663440" cy="4114800"/>
+            <a:off x="960120" y="1828800"/>
+            <a:ext cx="4754880" cy="4297680"/>
           </a:xfrm>
           <a:prstGeom prst="rect">
             <a:avLst/>
@@ -4854,95 +5965,95 @@
           <a:lstStyle/>
           <a:p>
             <a:pPr>
-              <a:defRPr sz="1600" b="1">
-                <a:solidFill>
-                  <a:srgbClr val="0F172A"/>
-                </a:solidFill>
-              </a:defRPr>
-            </a:pPr>
-            <a:r>
-              <a:t>Q3: Avoiding Hiding Genuine Comments</a:t>
+              <a:defRPr sz="1500" b="1">
+                <a:solidFill>
+                  <a:srgbClr val="059669"/>
+                </a:solidFill>
+              </a:defRPr>
+            </a:pPr>
+            <a:r>
+              <a:t>Question 3: How to avoid hiding genuine comments?</a:t>
             </a:r>
           </a:p>
           <a:p>
             <a:pPr>
               <a:spcBef>
-                <a:spcPts val="1000"/>
+                <a:spcPts val="800"/>
               </a:spcBef>
               <a:defRPr b="1" sz="1100">
                 <a:solidFill>
-                  <a:srgbClr val="059669"/>
-                </a:solidFill>
-              </a:defRPr>
-            </a:pPr>
-            <a:r>
-              <a:t>• Cooking Context Aware Model: </a:t>
+                  <a:srgbClr val="0F172A"/>
+                </a:solidFill>
+              </a:defRPr>
+            </a:pPr>
+            <a:r>
+              <a:t>• Cooking Lexicon Awareness:</a:t>
             </a:r>
           </a:p>
           <a:p>
             <a:pPr>
-              <a:defRPr sz="1050">
-                <a:solidFill>
-                  <a:srgbClr val="0F172A"/>
-                </a:solidFill>
-              </a:defRPr>
-            </a:pPr>
-            <a:r>
-              <a:t>Culinary terms like 'beat the eggs', 'kill the heat', or 'to die for' would trigger naive filters. DistilBERT evaluates sentence-level context to recognize culinary enthusiasm and technique.</a:t>
+              <a:defRPr sz="1000">
+                <a:solidFill>
+                  <a:srgbClr val="64748B"/>
+                </a:solidFill>
+              </a:defRPr>
+            </a:pPr>
+            <a:r>
+              <a:t>Cooking videos use violent-sounding words that are actually harmless: 'beat the eggs', 'kill the heat', 'killer recipe', 'to die for'. DistilBERT analyzes whole-sentence context so culinary passion is never mislabeled as violence.</a:t>
             </a:r>
           </a:p>
           <a:p>
             <a:pPr>
               <a:spcBef>
-                <a:spcPts val="1000"/>
+                <a:spcPts val="800"/>
               </a:spcBef>
               <a:defRPr b="1" sz="1100">
                 <a:solidFill>
-                  <a:srgbClr val="059669"/>
-                </a:solidFill>
-              </a:defRPr>
-            </a:pPr>
-            <a:r>
-              <a:t>• Asymmetric High Confidence Bar: </a:t>
+                  <a:srgbClr val="0F172A"/>
+                </a:solidFill>
+              </a:defRPr>
+            </a:pPr>
+            <a:r>
+              <a:t>• Asymmetric 90% Auto-Hide Threshold:</a:t>
             </a:r>
           </a:p>
           <a:p>
             <a:pPr>
-              <a:defRPr sz="1050">
-                <a:solidFill>
-                  <a:srgbClr val="0F172A"/>
-                </a:solidFill>
-              </a:defRPr>
-            </a:pPr>
-            <a:r>
-              <a:t>We require ≥90% confidence to auto-hide. Borderline comments (75% spam) are routed to human review rather than being hidden by mistake. Preserving genuine audience engagement is priority #1.</a:t>
+              <a:defRPr sz="1000">
+                <a:solidFill>
+                  <a:srgbClr val="64748B"/>
+                </a:solidFill>
+              </a:defRPr>
+            </a:pPr>
+            <a:r>
+              <a:t>We enforce a strict 90% confidence requirement to auto-hide. If the AI is only 75% sure an item is spam, it is NEVER hidden automatically; it is routed to human review. Protecting fan engagement is priority #1.</a:t>
             </a:r>
           </a:p>
           <a:p>
             <a:pPr>
               <a:spcBef>
-                <a:spcPts val="1000"/>
+                <a:spcPts val="800"/>
               </a:spcBef>
               <a:defRPr b="1" sz="1100">
                 <a:solidFill>
-                  <a:srgbClr val="059669"/>
-                </a:solidFill>
-              </a:defRPr>
-            </a:pPr>
-            <a:r>
-              <a:t>• Creator Appeal &amp; Held Queue: </a:t>
+                  <a:srgbClr val="0F172A"/>
+                </a:solidFill>
+              </a:defRPr>
+            </a:pPr>
+            <a:r>
+              <a:t>• Creator Controls &amp; One-Click Appeal:</a:t>
             </a:r>
           </a:p>
           <a:p>
             <a:pPr>
-              <a:defRPr sz="1050">
-                <a:solidFill>
-                  <a:srgbClr val="0F172A"/>
-                </a:solidFill>
-              </a:defRPr>
-            </a:pPr>
-            <a:r>
-              <a:t>Creators have access to a 'Held for Review' panel to restore false hides with 1 click. Users can submit an appeal, which reweights mislabeled comments in the training set.</a:t>
+              <a:defRPr sz="1000">
+                <a:solidFill>
+                  <a:srgbClr val="64748B"/>
+                </a:solidFill>
+              </a:defRPr>
+            </a:pPr>
+            <a:r>
+              <a:t>Creators have a 'Held for Review' panel where they can restore any comment with 1 click. Users can tap 'Appeal Decision'. Overturned decisions are tagged as mislabels and given higher weight during retraining.</a:t>
             </a:r>
           </a:p>
         </p:txBody>
@@ -4956,7 +6067,7 @@
         <p:spPr>
           <a:xfrm>
             <a:off x="6217920" y="1645920"/>
-            <a:ext cx="5212080" cy="4480560"/>
+            <a:ext cx="5212080" cy="4663440"/>
           </a:xfrm>
           <a:prstGeom prst="roundRect">
             <a:avLst/>
@@ -5000,8 +6111,8 @@
         </p:nvSpPr>
         <p:spPr>
           <a:xfrm>
-            <a:off x="6492240" y="1828800"/>
-            <a:ext cx="4663440" cy="4114800"/>
+            <a:off x="6446520" y="1828800"/>
+            <a:ext cx="4754880" cy="4297680"/>
           </a:xfrm>
           <a:prstGeom prst="rect">
             <a:avLst/>
@@ -5015,95 +6126,327 @@
           <a:lstStyle/>
           <a:p>
             <a:pPr>
-              <a:defRPr sz="1600" b="1">
-                <a:solidFill>
-                  <a:srgbClr val="0F172A"/>
-                </a:solidFill>
-              </a:defRPr>
-            </a:pPr>
-            <a:r>
-              <a:t>Q4: Keeping Up with New Spam Tricks</a:t>
+              <a:defRPr sz="1500" b="1">
+                <a:solidFill>
+                  <a:srgbClr val="D97706"/>
+                </a:solidFill>
+              </a:defRPr>
+            </a:pPr>
+            <a:r>
+              <a:t>Question 4: How to keep up with new spam tricks?</a:t>
             </a:r>
           </a:p>
           <a:p>
             <a:pPr>
               <a:spcBef>
-                <a:spcPts val="1000"/>
+                <a:spcPts val="800"/>
               </a:spcBef>
               <a:defRPr b="1" sz="1100">
                 <a:solidFill>
-                  <a:srgbClr val="D97706"/>
-                </a:solidFill>
-              </a:defRPr>
-            </a:pPr>
-            <a:r>
-              <a:t>• Active Learning Feedback Loop: </a:t>
+                  <a:srgbClr val="0F172A"/>
+                </a:solidFill>
+              </a:defRPr>
+            </a:pPr>
+            <a:r>
+              <a:t>• Active Learning Feedback Loop:</a:t>
             </a:r>
           </a:p>
           <a:p>
             <a:pPr>
-              <a:defRPr sz="1050">
-                <a:solidFill>
-                  <a:srgbClr val="0F172A"/>
-                </a:solidFill>
-              </a:defRPr>
-            </a:pPr>
-            <a:r>
-              <a:t>Every moderator action (Approve/Hide/Escalate) becomes a labeled training example. The 2 moderators generate ~300 verified labels daily, continuously training the system on emerging tricks.</a:t>
+              <a:defRPr sz="1000">
+                <a:solidFill>
+                  <a:srgbClr val="64748B"/>
+                </a:solidFill>
+              </a:defRPr>
+            </a:pPr>
+            <a:r>
+              <a:t>Every Approve, Hide, or Escalate decision made by the 2 moderators becomes a verified labeled training sample (~300 fresh human labels daily).</a:t>
             </a:r>
           </a:p>
           <a:p>
             <a:pPr>
               <a:spcBef>
-                <a:spcPts val="1000"/>
+                <a:spcPts val="800"/>
               </a:spcBef>
               <a:defRPr b="1" sz="1100">
                 <a:solidFill>
-                  <a:srgbClr val="D97706"/>
-                </a:solidFill>
-              </a:defRPr>
-            </a:pPr>
-            <a:r>
-              <a:t>• Adversarial Text Normalization: </a:t>
+                  <a:srgbClr val="0F172A"/>
+                </a:solidFill>
+              </a:defRPr>
+            </a:pPr>
+            <a:r>
+              <a:t>• Adversarial Text Normalization:</a:t>
             </a:r>
           </a:p>
           <a:p>
             <a:pPr>
-              <a:defRPr sz="1050">
-                <a:solidFill>
-                  <a:srgbClr val="0F172A"/>
-                </a:solidFill>
-              </a:defRPr>
-            </a:pPr>
-            <a:r>
-              <a:t>Spammers use spaces ('c-h-e-a-p'), zero-width unicode characters, and homoglyphs. Layer 1 preprocessing normalizes unicode characters and unshortens redirect links before classification.</a:t>
+              <a:defRPr sz="1000">
+                <a:solidFill>
+                  <a:srgbClr val="64748B"/>
+                </a:solidFill>
+              </a:defRPr>
+            </a:pPr>
+            <a:r>
+              <a:t>Spammers try tricks like spacing out words ('c-h-e-a-p'), zero-width Unicode characters, and URL shorteners. Our Tier 1 preprocessor normalizes characters and unshortens links before classification.</a:t>
             </a:r>
           </a:p>
           <a:p>
             <a:pPr>
               <a:spcBef>
-                <a:spcPts val="1000"/>
+                <a:spcPts val="800"/>
               </a:spcBef>
               <a:defRPr b="1" sz="1100">
                 <a:solidFill>
-                  <a:srgbClr val="D97706"/>
-                </a:solidFill>
-              </a:defRPr>
-            </a:pPr>
-            <a:r>
-              <a:t>• Weekly Retraining &amp; Drift Monitoring: </a:t>
+                  <a:srgbClr val="0F172A"/>
+                </a:solidFill>
+              </a:defRPr>
+            </a:pPr>
+            <a:r>
+              <a:t>• Weekly Automated Model Retraining:</a:t>
             </a:r>
           </a:p>
           <a:p>
             <a:pPr>
-              <a:defRPr sz="1050">
+              <a:defRPr sz="1000">
+                <a:solidFill>
+                  <a:srgbClr val="64748B"/>
+                </a:solidFill>
+              </a:defRPr>
+            </a:pPr>
+            <a:r>
+              <a:t>DistilBERT is fine-tuned weekly on fresh moderator labels (takes &lt;5 minutes on CPU). Drift monitoring tracks weekly false positive rates; if drift exceeds 2.5%, thresholds automatically recalibrate.</a:t>
+            </a:r>
+          </a:p>
+        </p:txBody>
+      </p:sp>
+    </p:spTree>
+  </p:cSld>
+  <p:clrMapOvr>
+    <a:masterClrMapping/>
+  </p:clrMapOvr>
+</p:sld>
+</file>
+
+<file path=ppt/slides/slide5.xml><?xml version="1.0" encoding="utf-8"?>
+<p:sld xmlns:a="http://schemas.openxmlformats.org/drawingml/2006/main" xmlns:p="http://schemas.openxmlformats.org/presentationml/2006/main" xmlns:r="http://schemas.openxmlformats.org/officeDocument/2006/relationships">
+  <p:cSld>
+    <p:spTree>
+      <p:nvGrpSpPr>
+        <p:cNvPr id="1" name=""/>
+        <p:cNvGrpSpPr/>
+        <p:nvPr/>
+      </p:nvGrpSpPr>
+      <p:grpSpPr/>
+      <p:sp>
+        <p:nvSpPr>
+          <p:cNvPr id="2" name="Rectangle 1"/>
+          <p:cNvSpPr/>
+          <p:nvPr/>
+        </p:nvSpPr>
+        <p:spPr>
+          <a:xfrm>
+            <a:off x="0" y="0"/>
+            <a:ext cx="12191695" cy="6858000"/>
+          </a:xfrm>
+          <a:prstGeom prst="rect">
+            <a:avLst/>
+          </a:prstGeom>
+          <a:solidFill>
+            <a:srgbClr val="FAF8F5"/>
+          </a:solidFill>
+          <a:ln>
+            <a:noFill/>
+          </a:ln>
+        </p:spPr>
+        <p:style>
+          <a:lnRef idx="1">
+            <a:schemeClr val="accent1"/>
+          </a:lnRef>
+          <a:fillRef idx="3">
+            <a:schemeClr val="accent1"/>
+          </a:fillRef>
+          <a:effectRef idx="2">
+            <a:schemeClr val="accent1"/>
+          </a:effectRef>
+          <a:fontRef idx="minor">
+            <a:schemeClr val="lt1"/>
+          </a:fontRef>
+        </p:style>
+        <p:txBody>
+          <a:bodyPr rtlCol="0" anchor="ctr"/>
+          <a:lstStyle/>
+          <a:p>
+            <a:pPr algn="ctr"/>
+          </a:p>
+        </p:txBody>
+      </p:sp>
+      <p:sp>
+        <p:nvSpPr>
+          <p:cNvPr id="3" name="Rounded Rectangle 2"/>
+          <p:cNvSpPr/>
+          <p:nvPr/>
+        </p:nvSpPr>
+        <p:spPr>
+          <a:xfrm>
+            <a:off x="1371600" y="914400"/>
+            <a:ext cx="9448495" cy="5029200"/>
+          </a:xfrm>
+          <a:prstGeom prst="roundRect">
+            <a:avLst/>
+          </a:prstGeom>
+          <a:solidFill>
+            <a:srgbClr val="FFFFFF"/>
+          </a:solidFill>
+          <a:ln w="19050">
+            <a:solidFill>
+              <a:srgbClr val="E2E8F0"/>
+            </a:solidFill>
+          </a:ln>
+        </p:spPr>
+        <p:style>
+          <a:lnRef idx="1">
+            <a:schemeClr val="accent1"/>
+          </a:lnRef>
+          <a:fillRef idx="3">
+            <a:schemeClr val="accent1"/>
+          </a:fillRef>
+          <a:effectRef idx="2">
+            <a:schemeClr val="accent1"/>
+          </a:effectRef>
+          <a:fontRef idx="minor">
+            <a:schemeClr val="lt1"/>
+          </a:fontRef>
+        </p:style>
+        <p:txBody>
+          <a:bodyPr rtlCol="0" anchor="ctr"/>
+          <a:lstStyle/>
+          <a:p>
+            <a:pPr algn="ctr"/>
+          </a:p>
+        </p:txBody>
+      </p:sp>
+      <p:sp>
+        <p:nvSpPr>
+          <p:cNvPr id="4" name="TextBox 3"/>
+          <p:cNvSpPr txBox="1"/>
+          <p:nvPr/>
+        </p:nvSpPr>
+        <p:spPr>
+          <a:xfrm>
+            <a:off x="1645920" y="1188720"/>
+            <a:ext cx="8899855" cy="4480560"/>
+          </a:xfrm>
+          <a:prstGeom prst="rect">
+            <a:avLst/>
+          </a:prstGeom>
+          <a:noFill/>
+        </p:spPr>
+        <p:txBody>
+          <a:bodyPr wrap="square">
+            <a:spAutoFit/>
+          </a:bodyPr>
+          <a:lstStyle/>
+          <a:p>
+            <a:pPr algn="ctr">
+              <a:defRPr sz="1200" b="1">
+                <a:solidFill>
+                  <a:srgbClr val="059669"/>
+                </a:solidFill>
+              </a:defRPr>
+            </a:pPr>
+            <a:r>
+              <a:t>PROTOTYPE DEPLOYED &amp; LIVE</a:t>
+            </a:r>
+          </a:p>
+          <a:p>
+            <a:pPr algn="ctr">
+              <a:spcBef>
+                <a:spcPts val="400"/>
+              </a:spcBef>
+              <a:defRPr sz="2800" b="1">
                 <a:solidFill>
                   <a:srgbClr val="0F172A"/>
                 </a:solidFill>
               </a:defRPr>
             </a:pPr>
             <a:r>
-              <a:t>Weekly automated fine-tuning of DistilBERT on new labels. Concept drift is monitored: if False Positive rate rises above 2.5%, thresholds and rules automatically re-calibrate.</a:t>
+              <a:t>CommentGuard AI Live Working Demo</a:t>
+            </a:r>
+          </a:p>
+          <a:p>
+            <a:pPr algn="ctr">
+              <a:spcBef>
+                <a:spcPts val="800"/>
+              </a:spcBef>
+              <a:defRPr sz="1200">
+                <a:solidFill>
+                  <a:srgbClr val="64748B"/>
+                </a:solidFill>
+              </a:defRPr>
+            </a:pPr>
+            <a:r>
+              <a:t>Click the link below to test the 3-Tier Cascade and Video Ingestion live in your browser:</a:t>
+            </a:r>
+          </a:p>
+          <a:p>
+            <a:pPr algn="ctr">
+              <a:spcBef>
+                <a:spcPts val="1400"/>
+              </a:spcBef>
+            </a:pPr>
+            <a:r>
+              <a:rPr sz="1800" b="1" u="sng">
+                <a:solidFill>
+                  <a:srgbClr val="2563EB"/>
+                </a:solidFill>
+                <a:hlinkClick r:id="rId2"/>
+              </a:rPr>
+              <a:t>👉 https://commentguard-ai.onrender.com/ 👈</a:t>
+            </a:r>
+          </a:p>
+          <a:p>
+            <a:pPr algn="ctr">
+              <a:spcBef>
+                <a:spcPts val="2000"/>
+              </a:spcBef>
+              <a:defRPr sz="1100" b="1">
+                <a:solidFill>
+                  <a:srgbClr val="059669"/>
+                </a:solidFill>
+              </a:defRPr>
+            </a:pPr>
+            <a:r>
+              <a:t>✓ 20,000 Comments Daily Handled   |   ✓ 94% Automated   |   ✓ ~20ms Latency   |   ✓ &lt;$2/Month Cost</a:t>
+            </a:r>
+          </a:p>
+          <a:p>
+            <a:pPr algn="ctr">
+              <a:spcBef>
+                <a:spcPts val="2400"/>
+              </a:spcBef>
+              <a:defRPr sz="2000" b="1">
+                <a:solidFill>
+                  <a:srgbClr val="0F172A"/>
+                </a:solidFill>
+              </a:defRPr>
+            </a:pPr>
+            <a:r>
+              <a:t>Thank You! Ready for Questions &amp; Live Demonstration.</a:t>
+            </a:r>
+          </a:p>
+          <a:p>
+            <a:pPr algn="ctr">
+              <a:spcBef>
+                <a:spcPts val="600"/>
+              </a:spcBef>
+              <a:defRPr sz="1100">
+                <a:solidFill>
+                  <a:srgbClr val="64748B"/>
+                </a:solidFill>
+              </a:defRPr>
+            </a:pPr>
+            <a:r>
+              <a:t>Dhanush Bheemsetty · dhanushbheemisetty0@gmail.com · Reg No: 2200030834</a:t>
             </a:r>
           </a:p>
         </p:txBody>
@@ -5434,4 +6777,324 @@
   </a:objectDefaults>
   <a:extraClrSchemeLst/>
 </a:theme>
+</file>
+
+<file path=ppt/theme/theme2.xml><?xml version="1.0" encoding="utf-8"?>
+<a:theme xmlns:a="http://schemas.openxmlformats.org/drawingml/2006/main" name="Office Theme">
+  <a:themeElements>
+    <a:clrScheme name="Office">
+      <a:dk1>
+        <a:sysClr val="windowText" lastClr="000000"/>
+      </a:dk1>
+      <a:lt1>
+        <a:sysClr val="window" lastClr="FFFFFF"/>
+      </a:lt1>
+      <a:dk2>
+        <a:srgbClr val="1F497D"/>
+      </a:dk2>
+      <a:lt2>
+        <a:srgbClr val="EEECE1"/>
+      </a:lt2>
+      <a:accent1>
+        <a:srgbClr val="4F81BD"/>
+      </a:accent1>
+      <a:accent2>
+        <a:srgbClr val="C0504D"/>
+      </a:accent2>
+      <a:accent3>
+        <a:srgbClr val="9BBB59"/>
+      </a:accent3>
+      <a:accent4>
+        <a:srgbClr val="8064A2"/>
+      </a:accent4>
+      <a:accent5>
+        <a:srgbClr val="4BACC6"/>
+      </a:accent5>
+      <a:accent6>
+        <a:srgbClr val="F79646"/>
+      </a:accent6>
+      <a:hlink>
+        <a:srgbClr val="0000FF"/>
+      </a:hlink>
+      <a:folHlink>
+        <a:srgbClr val="800080"/>
+      </a:folHlink>
+    </a:clrScheme>
+    <a:fontScheme name="Office">
+      <a:majorFont>
+        <a:latin typeface="Calibri"/>
+        <a:ea typeface=""/>
+        <a:cs typeface=""/>
+        <a:font script="Jpan" typeface="ＭＳ Ｐゴシック"/>
+        <a:font script="Hang" typeface="맑은 고딕"/>
+        <a:font script="Hans" typeface="宋体"/>
+        <a:font script="Hant" typeface="新細明體"/>
+        <a:font script="Arab" typeface="Times New Roman"/>
+        <a:font script="Hebr" typeface="Times New Roman"/>
+        <a:font script="Thai" typeface="Angsana New"/>
+        <a:font script="Ethi" typeface="Nyala"/>
+        <a:font script="Beng" typeface="Vrinda"/>
+        <a:font script="Gujr" typeface="Shruti"/>
+        <a:font script="Khmr" typeface="MoolBoran"/>
+        <a:font script="Knda" typeface="Tunga"/>
+        <a:font script="Guru" typeface="Raavi"/>
+        <a:font script="Cans" typeface="Euphemia"/>
+        <a:font script="Cher" typeface="Plantagenet Cherokee"/>
+        <a:font script="Yiii" typeface="Microsoft Yi Baiti"/>
+        <a:font script="Tibt" typeface="Microsoft Himalaya"/>
+        <a:font script="Thaa" typeface="MV Boli"/>
+        <a:font script="Deva" typeface="Mangal"/>
+        <a:font script="Telu" typeface="Gautami"/>
+        <a:font script="Taml" typeface="Latha"/>
+        <a:font script="Syrc" typeface="Estrangelo Edessa"/>
+        <a:font script="Orya" typeface="Kalinga"/>
+        <a:font script="Mlym" typeface="Kartika"/>
+        <a:font script="Laoo" typeface="DokChampa"/>
+        <a:font script="Sinh" typeface="Iskoola Pota"/>
+        <a:font script="Mong" typeface="Mongolian Baiti"/>
+        <a:font script="Viet" typeface="Times New Roman"/>
+        <a:font script="Uigh" typeface="Microsoft Uighur"/>
+        <a:font script="Geor" typeface="Sylfaen"/>
+      </a:majorFont>
+      <a:minorFont>
+        <a:latin typeface="Calibri"/>
+        <a:ea typeface=""/>
+        <a:cs typeface=""/>
+        <a:font script="Jpan" typeface="ＭＳ Ｐゴシック"/>
+        <a:font script="Hang" typeface="맑은 고딕"/>
+        <a:font script="Hans" typeface="宋体"/>
+        <a:font script="Hant" typeface="新細明體"/>
+        <a:font script="Arab" typeface="Arial"/>
+        <a:font script="Hebr" typeface="Arial"/>
+        <a:font script="Thai" typeface="Cordia New"/>
+        <a:font script="Ethi" typeface="Nyala"/>
+        <a:font script="Beng" typeface="Vrinda"/>
+        <a:font script="Gujr" typeface="Shruti"/>
+        <a:font script="Khmr" typeface="DaunPenh"/>
+        <a:font script="Knda" typeface="Tunga"/>
+        <a:font script="Guru" typeface="Raavi"/>
+        <a:font script="Cans" typeface="Euphemia"/>
+        <a:font script="Cher" typeface="Plantagenet Cherokee"/>
+        <a:font script="Yiii" typeface="Microsoft Yi Baiti"/>
+        <a:font script="Tibt" typeface="Microsoft Himalaya"/>
+        <a:font script="Thaa" typeface="MV Boli"/>
+        <a:font script="Deva" typeface="Mangal"/>
+        <a:font script="Telu" typeface="Gautami"/>
+        <a:font script="Taml" typeface="Latha"/>
+        <a:font script="Syrc" typeface="Estrangelo Edessa"/>
+        <a:font script="Orya" typeface="Kalinga"/>
+        <a:font script="Mlym" typeface="Kartika"/>
+        <a:font script="Laoo" typeface="DokChampa"/>
+        <a:font script="Sinh" typeface="Iskoola Pota"/>
+        <a:font script="Mong" typeface="Mongolian Baiti"/>
+        <a:font script="Viet" typeface="Arial"/>
+        <a:font script="Uigh" typeface="Microsoft Uighur"/>
+        <a:font script="Geor" typeface="Sylfaen"/>
+      </a:minorFont>
+    </a:fontScheme>
+    <a:fmtScheme name="Office">
+      <a:fillStyleLst>
+        <a:solidFill>
+          <a:schemeClr val="phClr"/>
+        </a:solidFill>
+        <a:gradFill rotWithShape="1">
+          <a:gsLst>
+            <a:gs pos="0">
+              <a:schemeClr val="phClr">
+                <a:tint val="50000"/>
+                <a:satMod val="300000"/>
+              </a:schemeClr>
+            </a:gs>
+            <a:gs pos="35000">
+              <a:schemeClr val="phClr">
+                <a:tint val="37000"/>
+                <a:satMod val="300000"/>
+              </a:schemeClr>
+            </a:gs>
+            <a:gs pos="100000">
+              <a:schemeClr val="phClr">
+                <a:tint val="15000"/>
+                <a:satMod val="350000"/>
+              </a:schemeClr>
+            </a:gs>
+          </a:gsLst>
+          <a:lin ang="16200000" scaled="1"/>
+        </a:gradFill>
+        <a:gradFill rotWithShape="1">
+          <a:gsLst>
+            <a:gs pos="0">
+              <a:schemeClr val="phClr">
+                <a:tint val="100000"/>
+                <a:shade val="100000"/>
+                <a:satMod val="130000"/>
+              </a:schemeClr>
+            </a:gs>
+            <a:gs pos="100000">
+              <a:schemeClr val="phClr">
+                <a:tint val="50000"/>
+                <a:shade val="100000"/>
+                <a:satMod val="350000"/>
+              </a:schemeClr>
+            </a:gs>
+          </a:gsLst>
+          <a:lin ang="16200000" scaled="0"/>
+        </a:gradFill>
+      </a:fillStyleLst>
+      <a:lnStyleLst>
+        <a:ln w="9525" cap="flat" cmpd="sng" algn="ctr">
+          <a:solidFill>
+            <a:schemeClr val="phClr">
+              <a:shade val="95000"/>
+              <a:satMod val="105000"/>
+            </a:schemeClr>
+          </a:solidFill>
+          <a:prstDash val="solid"/>
+        </a:ln>
+        <a:ln w="25400" cap="flat" cmpd="sng" algn="ctr">
+          <a:solidFill>
+            <a:schemeClr val="phClr"/>
+          </a:solidFill>
+          <a:prstDash val="solid"/>
+        </a:ln>
+        <a:ln w="38100" cap="flat" cmpd="sng" algn="ctr">
+          <a:solidFill>
+            <a:schemeClr val="phClr"/>
+          </a:solidFill>
+          <a:prstDash val="solid"/>
+        </a:ln>
+      </a:lnStyleLst>
+      <a:effectStyleLst>
+        <a:effectStyle>
+          <a:effectLst>
+            <a:outerShdw blurRad="40000" dist="20000" dir="5400000" rotWithShape="0">
+              <a:srgbClr val="000000">
+                <a:alpha val="38000"/>
+              </a:srgbClr>
+            </a:outerShdw>
+          </a:effectLst>
+        </a:effectStyle>
+        <a:effectStyle>
+          <a:effectLst>
+            <a:outerShdw blurRad="40000" dist="23000" dir="5400000" rotWithShape="0">
+              <a:srgbClr val="000000">
+                <a:alpha val="35000"/>
+              </a:srgbClr>
+            </a:outerShdw>
+          </a:effectLst>
+        </a:effectStyle>
+        <a:effectStyle>
+          <a:effectLst>
+            <a:outerShdw blurRad="40000" dist="23000" dir="5400000" rotWithShape="0">
+              <a:srgbClr val="000000">
+                <a:alpha val="35000"/>
+              </a:srgbClr>
+            </a:outerShdw>
+          </a:effectLst>
+          <a:scene3d>
+            <a:camera prst="orthographicFront">
+              <a:rot lat="0" lon="0" rev="0"/>
+            </a:camera>
+            <a:lightRig rig="threePt" dir="t">
+              <a:rot lat="0" lon="0" rev="1200000"/>
+            </a:lightRig>
+          </a:scene3d>
+          <a:sp3d>
+            <a:bevelT w="63500" h="25400"/>
+          </a:sp3d>
+        </a:effectStyle>
+      </a:effectStyleLst>
+      <a:bgFillStyleLst>
+        <a:solidFill>
+          <a:schemeClr val="phClr"/>
+        </a:solidFill>
+        <a:gradFill rotWithShape="1">
+          <a:gsLst>
+            <a:gs pos="0">
+              <a:schemeClr val="phClr">
+                <a:tint val="40000"/>
+                <a:satMod val="350000"/>
+              </a:schemeClr>
+            </a:gs>
+            <a:gs pos="40000">
+              <a:schemeClr val="phClr">
+                <a:tint val="45000"/>
+                <a:shade val="99000"/>
+                <a:satMod val="350000"/>
+              </a:schemeClr>
+            </a:gs>
+            <a:gs pos="100000">
+              <a:schemeClr val="phClr">
+                <a:shade val="20000"/>
+                <a:satMod val="255000"/>
+              </a:schemeClr>
+            </a:gs>
+          </a:gsLst>
+          <a:path path="circle">
+            <a:fillToRect l="50000" t="-80000" r="50000" b="180000"/>
+          </a:path>
+        </a:gradFill>
+        <a:gradFill rotWithShape="1">
+          <a:gsLst>
+            <a:gs pos="0">
+              <a:schemeClr val="phClr">
+                <a:tint val="80000"/>
+                <a:satMod val="300000"/>
+              </a:schemeClr>
+            </a:gs>
+            <a:gs pos="100000">
+              <a:schemeClr val="phClr">
+                <a:shade val="30000"/>
+                <a:satMod val="200000"/>
+              </a:schemeClr>
+            </a:gs>
+          </a:gsLst>
+          <a:path path="circle">
+            <a:fillToRect l="50000" t="50000" r="50000" b="50000"/>
+          </a:path>
+        </a:gradFill>
+      </a:bgFillStyleLst>
+    </a:fmtScheme>
+  </a:themeElements>
+  <a:objectDefaults>
+    <a:spDef>
+      <a:spPr/>
+      <a:bodyPr/>
+      <a:lstStyle/>
+      <a:style>
+        <a:lnRef idx="1">
+          <a:schemeClr val="accent1"/>
+        </a:lnRef>
+        <a:fillRef idx="3">
+          <a:schemeClr val="accent1"/>
+        </a:fillRef>
+        <a:effectRef idx="2">
+          <a:schemeClr val="accent1"/>
+        </a:effectRef>
+        <a:fontRef idx="minor">
+          <a:schemeClr val="lt1"/>
+        </a:fontRef>
+      </a:style>
+    </a:spDef>
+    <a:lnDef>
+      <a:spPr/>
+      <a:bodyPr/>
+      <a:lstStyle/>
+      <a:style>
+        <a:lnRef idx="2">
+          <a:schemeClr val="accent1"/>
+        </a:lnRef>
+        <a:fillRef idx="0">
+          <a:schemeClr val="accent1"/>
+        </a:fillRef>
+        <a:effectRef idx="1">
+          <a:schemeClr val="accent1"/>
+        </a:effectRef>
+        <a:fontRef idx="minor">
+          <a:schemeClr val="tx1"/>
+        </a:fontRef>
+      </a:style>
+    </a:lnDef>
+  </a:objectDefaults>
+  <a:extraClrSchemeLst/>
+</a:theme>
 </file>
</xml_diff>